<commit_message>
docs: orienta la portada al caso de uso real
</commit_message>
<xml_diff>
--- a/docs/presentaciones/evolucion-native-ai/evolucion-native-ai-v2.pptx
+++ b/docs/presentaciones/evolucion-native-ai/evolucion-native-ai-v2.pptx
@@ -3246,7 +3246,7 @@
         <p:spPr>
           <a:xfrm>
             <a:off x="640080" y="1097280"/>
-            <a:ext cx="8138160" cy="960120"/>
+            <a:ext cx="8138160" cy="1078992"/>
           </a:xfrm>
           <a:prstGeom prst="rect">
             <a:avLst/>
@@ -3264,9 +3264,9 @@
                 <a:spcPct val="100000"/>
               </a:lnSpc>
               <a:spcAft>
-                <a:spcPts val="408"/>
-              </a:spcAft>
-              <a:defRPr sz="3400" b="1">
+                <a:spcPts val="384"/>
+              </a:spcAft>
+              <a:defRPr sz="3200" b="1">
                 <a:solidFill>
                   <a:srgbClr val="FFFFFF"/>
                 </a:solidFill>
@@ -3274,7 +3274,7 @@
               </a:defRPr>
             </a:pPr>
             <a:r>
-              <a:t>De la especificación a la entrega</a:t>
+              <a:t>Evolución de Native AI en un proyecto real</a:t>
             </a:r>
           </a:p>
         </p:txBody>
@@ -3316,7 +3316,7 @@
               </a:defRPr>
             </a:pPr>
             <a:r>
-              <a:t>La evolución de Native AI: conecta lo que pide el cliente, lo que construye el equipo y la evidencia con la que se decide.</a:t>
+              <a:t>Qué cambió al aplicar la metodología original con clientes: más cobertura, más control y evidencia medible.</a:t>
             </a:r>
           </a:p>
         </p:txBody>
@@ -3963,7 +3963,7 @@
               </a:defRPr>
             </a:pPr>
             <a:r>
-              <a:t>Evolución de Native AI · metodología original → marketplace v1.46.1</a:t>
+              <a:t>Metodología original → aprendizaje en cliente → marketplace v1.46.1</a:t>
             </a:r>
           </a:p>
         </p:txBody>

</xml_diff>

<commit_message>
docs: trae al deck el grafico de las seis cosas que hace mejor
Es el que ya estaba en el informe HTML y es el que mejor cuenta el
matiz: en azul lo que el metodo ya daba, en ambar lo que hemos sumado
encima. Apilado a proposito, para que se lea como que construimos sobre
su trabajo y no contra el.

Se conserva la nota de que es una valoracion del equipo y no una
medicion, y la frase de que donde no hay tramo azul no es que el metodo
fallara, sino que eso no entraba en lo que se propuso resolver. Sin esa
linea el grafico dice algo que no es verdad.

verify() pasa a exigir seis.

Co-Authored-By: Claude Opus 5 <noreply@anthropic.com>
</commit_message>
<xml_diff>
--- a/docs/presentaciones/evolucion-native-ai/evolucion-native-ai-v2.pptx
+++ b/docs/presentaciones/evolucion-native-ai/evolucion-native-ai-v2.pptx
@@ -10,6 +10,7 @@
     <p:sldId id="258" r:id="rId9"/>
     <p:sldId id="259" r:id="rId10"/>
     <p:sldId id="260" r:id="rId11"/>
+    <p:sldId id="261" r:id="rId12"/>
   </p:sldIdLst>
   <p:sldSz cx="12191695" cy="6858000" type="screen4x3"/>
   <p:notesSz cx="6858000" cy="9144000"/>
@@ -3961,7 +3962,7 @@
               </a:defRPr>
             </a:pPr>
             <a:r>
-              <a:t>01 / 05</a:t>
+              <a:t>01 / 06</a:t>
             </a:r>
           </a:p>
         </p:txBody>
@@ -6179,7 +6180,7 @@
               </a:defRPr>
             </a:pPr>
             <a:r>
-              <a:t>02 / 05</a:t>
+              <a:t>02 / 06</a:t>
             </a:r>
           </a:p>
         </p:txBody>
@@ -8220,7 +8221,7 @@
               </a:defRPr>
             </a:pPr>
             <a:r>
-              <a:t>03 / 05</a:t>
+              <a:t>03 / 06</a:t>
             </a:r>
           </a:p>
         </p:txBody>
@@ -8325,7 +8326,7 @@
               </a:defRPr>
             </a:pPr>
             <a:r>
-              <a:t>LO QUE CAMBIA</a:t>
+              <a:t>EL SALTO, POR DENTRO</a:t>
             </a:r>
           </a:p>
         </p:txBody>
@@ -8367,7 +8368,7 @@
               </a:defRPr>
             </a:pPr>
             <a:r>
-              <a:t>Cuatro cosas que antes no podíamos hacer delante de un cliente</a:t>
+              <a:t>Seis cosas que hoy el método hace mejor</a:t>
             </a:r>
           </a:p>
         </p:txBody>
@@ -8409,7 +8410,7 @@
               </a:defRPr>
             </a:pPr>
             <a:r>
-              <a:t>El método terminaba en el código validado. Ahora llega hasta lo que el cliente firma y la cifra con la que nos juzga.</a:t>
+              <a:t>En azul, lo que el método ya daba. En ámbar, lo que hemos sumado encima.</a:t>
             </a:r>
           </a:p>
         </p:txBody>
@@ -8465,8 +8466,1406 @@
         </p:nvSpPr>
         <p:spPr>
           <a:xfrm>
-            <a:off x="566928" y="1975104"/>
-            <a:ext cx="5358384" cy="1664208"/>
+            <a:off x="7589520" y="1828800"/>
+            <a:ext cx="201168" cy="146304"/>
+          </a:xfrm>
+          <a:prstGeom prst="roundRect">
+            <a:avLst/>
+          </a:prstGeom>
+          <a:solidFill>
+            <a:srgbClr val="0072BC"/>
+          </a:solidFill>
+          <a:ln w="12700">
+            <a:solidFill>
+              <a:srgbClr val="0072BC"/>
+            </a:solidFill>
+          </a:ln>
+        </p:spPr>
+        <p:style>
+          <a:lnRef idx="1">
+            <a:schemeClr val="accent1"/>
+          </a:lnRef>
+          <a:fillRef idx="3">
+            <a:schemeClr val="accent1"/>
+          </a:fillRef>
+          <a:effectRef idx="2">
+            <a:schemeClr val="accent1"/>
+          </a:effectRef>
+          <a:fontRef idx="minor">
+            <a:schemeClr val="lt1"/>
+          </a:fontRef>
+        </p:style>
+        <p:txBody>
+          <a:bodyPr rtlCol="0" anchor="ctr"/>
+          <a:lstStyle/>
+          <a:p>
+            <a:pPr algn="ctr"/>
+          </a:p>
+        </p:txBody>
+      </p:sp>
+      <p:sp>
+        <p:nvSpPr>
+          <p:cNvPr id="8" name="TextBox 7"/>
+          <p:cNvSpPr txBox="1"/>
+          <p:nvPr/>
+        </p:nvSpPr>
+        <p:spPr>
+          <a:xfrm>
+            <a:off x="7882128" y="1792224"/>
+            <a:ext cx="1783080" cy="219456"/>
+          </a:xfrm>
+          <a:prstGeom prst="rect">
+            <a:avLst/>
+          </a:prstGeom>
+          <a:noFill/>
+        </p:spPr>
+        <p:txBody>
+          <a:bodyPr wrap="square" lIns="0" rIns="0" tIns="0" bIns="0" anchor="t">
+            <a:normAutofit/>
+          </a:bodyPr>
+          <a:lstStyle/>
+          <a:p>
+            <a:pPr algn="l">
+              <a:lnSpc>
+                <a:spcPct val="100000"/>
+              </a:lnSpc>
+              <a:spcAft>
+                <a:spcPts val="102"/>
+              </a:spcAft>
+              <a:defRPr sz="850" b="0">
+                <a:solidFill>
+                  <a:srgbClr val="3F556A"/>
+                </a:solidFill>
+                <a:latin typeface="Arial"/>
+              </a:defRPr>
+            </a:pPr>
+            <a:r>
+              <a:t>Lo que ya daba el método</a:t>
+            </a:r>
+          </a:p>
+        </p:txBody>
+      </p:sp>
+      <p:sp>
+        <p:nvSpPr>
+          <p:cNvPr id="9" name="Rounded Rectangle 8"/>
+          <p:cNvSpPr/>
+          <p:nvPr/>
+        </p:nvSpPr>
+        <p:spPr>
+          <a:xfrm>
+            <a:off x="9710928" y="1828800"/>
+            <a:ext cx="201168" cy="146304"/>
+          </a:xfrm>
+          <a:prstGeom prst="roundRect">
+            <a:avLst/>
+          </a:prstGeom>
+          <a:solidFill>
+            <a:srgbClr val="E8792E"/>
+          </a:solidFill>
+          <a:ln w="12700">
+            <a:solidFill>
+              <a:srgbClr val="E8792E"/>
+            </a:solidFill>
+          </a:ln>
+        </p:spPr>
+        <p:style>
+          <a:lnRef idx="1">
+            <a:schemeClr val="accent1"/>
+          </a:lnRef>
+          <a:fillRef idx="3">
+            <a:schemeClr val="accent1"/>
+          </a:fillRef>
+          <a:effectRef idx="2">
+            <a:schemeClr val="accent1"/>
+          </a:effectRef>
+          <a:fontRef idx="minor">
+            <a:schemeClr val="lt1"/>
+          </a:fontRef>
+        </p:style>
+        <p:txBody>
+          <a:bodyPr rtlCol="0" anchor="ctr"/>
+          <a:lstStyle/>
+          <a:p>
+            <a:pPr algn="ctr"/>
+          </a:p>
+        </p:txBody>
+      </p:sp>
+      <p:sp>
+        <p:nvSpPr>
+          <p:cNvPr id="10" name="TextBox 9"/>
+          <p:cNvSpPr txBox="1"/>
+          <p:nvPr/>
+        </p:nvSpPr>
+        <p:spPr>
+          <a:xfrm>
+            <a:off x="10003536" y="1792224"/>
+            <a:ext cx="1783080" cy="219456"/>
+          </a:xfrm>
+          <a:prstGeom prst="rect">
+            <a:avLst/>
+          </a:prstGeom>
+          <a:noFill/>
+        </p:spPr>
+        <p:txBody>
+          <a:bodyPr wrap="square" lIns="0" rIns="0" tIns="0" bIns="0" anchor="t">
+            <a:normAutofit/>
+          </a:bodyPr>
+          <a:lstStyle/>
+          <a:p>
+            <a:pPr algn="l">
+              <a:lnSpc>
+                <a:spcPct val="100000"/>
+              </a:lnSpc>
+              <a:spcAft>
+                <a:spcPts val="102"/>
+              </a:spcAft>
+              <a:defRPr sz="850" b="0">
+                <a:solidFill>
+                  <a:srgbClr val="3F556A"/>
+                </a:solidFill>
+                <a:latin typeface="Arial"/>
+              </a:defRPr>
+            </a:pPr>
+            <a:r>
+              <a:t>Lo que hemos sumado</a:t>
+            </a:r>
+          </a:p>
+        </p:txBody>
+      </p:sp>
+      <p:sp>
+        <p:nvSpPr>
+          <p:cNvPr id="11" name="TextBox 10"/>
+          <p:cNvSpPr txBox="1"/>
+          <p:nvPr/>
+        </p:nvSpPr>
+        <p:spPr>
+          <a:xfrm>
+            <a:off x="566928" y="2176272"/>
+            <a:ext cx="2285999" cy="274320"/>
+          </a:xfrm>
+          <a:prstGeom prst="rect">
+            <a:avLst/>
+          </a:prstGeom>
+          <a:noFill/>
+        </p:spPr>
+        <p:txBody>
+          <a:bodyPr wrap="square" lIns="0" rIns="0" tIns="0" bIns="0" anchor="ctr">
+            <a:normAutofit/>
+          </a:bodyPr>
+          <a:lstStyle/>
+          <a:p>
+            <a:pPr algn="r">
+              <a:lnSpc>
+                <a:spcPct val="100000"/>
+              </a:lnSpc>
+              <a:spcAft>
+                <a:spcPts val="126"/>
+              </a:spcAft>
+              <a:defRPr sz="1050" b="1">
+                <a:solidFill>
+                  <a:srgbClr val="17324D"/>
+                </a:solidFill>
+                <a:latin typeface="Arial"/>
+              </a:defRPr>
+            </a:pPr>
+            <a:r>
+              <a:t>Que cada paso tenga herramienta</a:t>
+            </a:r>
+          </a:p>
+        </p:txBody>
+      </p:sp>
+      <p:sp>
+        <p:nvSpPr>
+          <p:cNvPr id="12" name="Rounded Rectangle 11"/>
+          <p:cNvSpPr/>
+          <p:nvPr/>
+        </p:nvSpPr>
+        <p:spPr>
+          <a:xfrm>
+            <a:off x="3017520" y="2194560"/>
+            <a:ext cx="8549640" cy="219456"/>
+          </a:xfrm>
+          <a:prstGeom prst="roundRect">
+            <a:avLst/>
+          </a:prstGeom>
+          <a:solidFill>
+            <a:srgbClr val="E9ECEF"/>
+          </a:solidFill>
+          <a:ln w="12700">
+            <a:solidFill>
+              <a:srgbClr val="E9ECEF"/>
+            </a:solidFill>
+          </a:ln>
+        </p:spPr>
+        <p:style>
+          <a:lnRef idx="1">
+            <a:schemeClr val="accent1"/>
+          </a:lnRef>
+          <a:fillRef idx="3">
+            <a:schemeClr val="accent1"/>
+          </a:fillRef>
+          <a:effectRef idx="2">
+            <a:schemeClr val="accent1"/>
+          </a:effectRef>
+          <a:fontRef idx="minor">
+            <a:schemeClr val="lt1"/>
+          </a:fontRef>
+        </p:style>
+        <p:txBody>
+          <a:bodyPr rtlCol="0" anchor="ctr"/>
+          <a:lstStyle/>
+          <a:p>
+            <a:pPr algn="ctr"/>
+          </a:p>
+        </p:txBody>
+      </p:sp>
+      <p:sp>
+        <p:nvSpPr>
+          <p:cNvPr id="13" name="Rounded Rectangle 12"/>
+          <p:cNvSpPr/>
+          <p:nvPr/>
+        </p:nvSpPr>
+        <p:spPr>
+          <a:xfrm>
+            <a:off x="3017520" y="2194560"/>
+            <a:ext cx="3419856" cy="219456"/>
+          </a:xfrm>
+          <a:prstGeom prst="roundRect">
+            <a:avLst/>
+          </a:prstGeom>
+          <a:solidFill>
+            <a:srgbClr val="0072BC"/>
+          </a:solidFill>
+          <a:ln w="12700">
+            <a:solidFill>
+              <a:srgbClr val="0072BC"/>
+            </a:solidFill>
+          </a:ln>
+        </p:spPr>
+        <p:style>
+          <a:lnRef idx="1">
+            <a:schemeClr val="accent1"/>
+          </a:lnRef>
+          <a:fillRef idx="3">
+            <a:schemeClr val="accent1"/>
+          </a:fillRef>
+          <a:effectRef idx="2">
+            <a:schemeClr val="accent1"/>
+          </a:effectRef>
+          <a:fontRef idx="minor">
+            <a:schemeClr val="lt1"/>
+          </a:fontRef>
+        </p:style>
+        <p:txBody>
+          <a:bodyPr rtlCol="0" anchor="ctr"/>
+          <a:lstStyle/>
+          <a:p>
+            <a:pPr algn="ctr"/>
+          </a:p>
+        </p:txBody>
+      </p:sp>
+      <p:sp>
+        <p:nvSpPr>
+          <p:cNvPr id="14" name="Rounded Rectangle 13"/>
+          <p:cNvSpPr/>
+          <p:nvPr/>
+        </p:nvSpPr>
+        <p:spPr>
+          <a:xfrm>
+            <a:off x="6464808" y="2194560"/>
+            <a:ext cx="5129784" cy="219456"/>
+          </a:xfrm>
+          <a:prstGeom prst="roundRect">
+            <a:avLst/>
+          </a:prstGeom>
+          <a:solidFill>
+            <a:srgbClr val="E8792E"/>
+          </a:solidFill>
+          <a:ln w="12700">
+            <a:solidFill>
+              <a:srgbClr val="E8792E"/>
+            </a:solidFill>
+          </a:ln>
+        </p:spPr>
+        <p:style>
+          <a:lnRef idx="1">
+            <a:schemeClr val="accent1"/>
+          </a:lnRef>
+          <a:fillRef idx="3">
+            <a:schemeClr val="accent1"/>
+          </a:fillRef>
+          <a:effectRef idx="2">
+            <a:schemeClr val="accent1"/>
+          </a:effectRef>
+          <a:fontRef idx="minor">
+            <a:schemeClr val="lt1"/>
+          </a:fontRef>
+        </p:style>
+        <p:txBody>
+          <a:bodyPr rtlCol="0" anchor="ctr"/>
+          <a:lstStyle/>
+          <a:p>
+            <a:pPr algn="ctr"/>
+          </a:p>
+        </p:txBody>
+      </p:sp>
+      <p:sp>
+        <p:nvSpPr>
+          <p:cNvPr id="15" name="TextBox 14"/>
+          <p:cNvSpPr txBox="1"/>
+          <p:nvPr/>
+        </p:nvSpPr>
+        <p:spPr>
+          <a:xfrm>
+            <a:off x="3017520" y="2468879"/>
+            <a:ext cx="8549640" cy="219456"/>
+          </a:xfrm>
+          <a:prstGeom prst="rect">
+            <a:avLst/>
+          </a:prstGeom>
+          <a:noFill/>
+        </p:spPr>
+        <p:txBody>
+          <a:bodyPr wrap="square" lIns="0" rIns="0" tIns="0" bIns="0" anchor="t">
+            <a:normAutofit/>
+          </a:bodyPr>
+          <a:lstStyle/>
+          <a:p>
+            <a:pPr algn="l">
+              <a:lnSpc>
+                <a:spcPct val="100000"/>
+              </a:lnSpc>
+              <a:spcAft>
+                <a:spcPts val="103"/>
+              </a:spcAft>
+              <a:defRPr sz="860" b="0">
+                <a:solidFill>
+                  <a:srgbClr val="71808E"/>
+                </a:solidFill>
+                <a:latin typeface="Arial"/>
+              </a:defRPr>
+            </a:pPr>
+            <a:r>
+              <a:t>El método ya describía todos los pasos. Nosotros hemos hecho las herramientas que faltaban.</a:t>
+            </a:r>
+          </a:p>
+        </p:txBody>
+      </p:sp>
+      <p:sp>
+        <p:nvSpPr>
+          <p:cNvPr id="16" name="TextBox 15"/>
+          <p:cNvSpPr txBox="1"/>
+          <p:nvPr/>
+        </p:nvSpPr>
+        <p:spPr>
+          <a:xfrm>
+            <a:off x="566928" y="2798064"/>
+            <a:ext cx="2285999" cy="274320"/>
+          </a:xfrm>
+          <a:prstGeom prst="rect">
+            <a:avLst/>
+          </a:prstGeom>
+          <a:noFill/>
+        </p:spPr>
+        <p:txBody>
+          <a:bodyPr wrap="square" lIns="0" rIns="0" tIns="0" bIns="0" anchor="ctr">
+            <a:normAutofit/>
+          </a:bodyPr>
+          <a:lstStyle/>
+          <a:p>
+            <a:pPr algn="r">
+              <a:lnSpc>
+                <a:spcPct val="100000"/>
+              </a:lnSpc>
+              <a:spcAft>
+                <a:spcPts val="126"/>
+              </a:spcAft>
+              <a:defRPr sz="1050" b="1">
+                <a:solidFill>
+                  <a:srgbClr val="17324D"/>
+                </a:solidFill>
+                <a:latin typeface="Arial"/>
+              </a:defRPr>
+            </a:pPr>
+            <a:r>
+              <a:t>Enseñar resultados al cliente</a:t>
+            </a:r>
+          </a:p>
+        </p:txBody>
+      </p:sp>
+      <p:sp>
+        <p:nvSpPr>
+          <p:cNvPr id="17" name="Rounded Rectangle 16"/>
+          <p:cNvSpPr/>
+          <p:nvPr/>
+        </p:nvSpPr>
+        <p:spPr>
+          <a:xfrm>
+            <a:off x="3017520" y="2816352"/>
+            <a:ext cx="8549640" cy="219456"/>
+          </a:xfrm>
+          <a:prstGeom prst="roundRect">
+            <a:avLst/>
+          </a:prstGeom>
+          <a:solidFill>
+            <a:srgbClr val="E9ECEF"/>
+          </a:solidFill>
+          <a:ln w="12700">
+            <a:solidFill>
+              <a:srgbClr val="E9ECEF"/>
+            </a:solidFill>
+          </a:ln>
+        </p:spPr>
+        <p:style>
+          <a:lnRef idx="1">
+            <a:schemeClr val="accent1"/>
+          </a:lnRef>
+          <a:fillRef idx="3">
+            <a:schemeClr val="accent1"/>
+          </a:fillRef>
+          <a:effectRef idx="2">
+            <a:schemeClr val="accent1"/>
+          </a:effectRef>
+          <a:fontRef idx="minor">
+            <a:schemeClr val="lt1"/>
+          </a:fontRef>
+        </p:style>
+        <p:txBody>
+          <a:bodyPr rtlCol="0" anchor="ctr"/>
+          <a:lstStyle/>
+          <a:p>
+            <a:pPr algn="ctr"/>
+          </a:p>
+        </p:txBody>
+      </p:sp>
+      <p:sp>
+        <p:nvSpPr>
+          <p:cNvPr id="18" name="Rounded Rectangle 17"/>
+          <p:cNvSpPr/>
+          <p:nvPr/>
+        </p:nvSpPr>
+        <p:spPr>
+          <a:xfrm>
+            <a:off x="3017520" y="2816352"/>
+            <a:ext cx="7523683" cy="219456"/>
+          </a:xfrm>
+          <a:prstGeom prst="roundRect">
+            <a:avLst/>
+          </a:prstGeom>
+          <a:solidFill>
+            <a:srgbClr val="E8792E"/>
+          </a:solidFill>
+          <a:ln w="12700">
+            <a:solidFill>
+              <a:srgbClr val="E8792E"/>
+            </a:solidFill>
+          </a:ln>
+        </p:spPr>
+        <p:style>
+          <a:lnRef idx="1">
+            <a:schemeClr val="accent1"/>
+          </a:lnRef>
+          <a:fillRef idx="3">
+            <a:schemeClr val="accent1"/>
+          </a:fillRef>
+          <a:effectRef idx="2">
+            <a:schemeClr val="accent1"/>
+          </a:effectRef>
+          <a:fontRef idx="minor">
+            <a:schemeClr val="lt1"/>
+          </a:fontRef>
+        </p:style>
+        <p:txBody>
+          <a:bodyPr rtlCol="0" anchor="ctr"/>
+          <a:lstStyle/>
+          <a:p>
+            <a:pPr algn="ctr"/>
+          </a:p>
+        </p:txBody>
+      </p:sp>
+      <p:sp>
+        <p:nvSpPr>
+          <p:cNvPr id="19" name="TextBox 18"/>
+          <p:cNvSpPr txBox="1"/>
+          <p:nvPr/>
+        </p:nvSpPr>
+        <p:spPr>
+          <a:xfrm>
+            <a:off x="3017520" y="3090672"/>
+            <a:ext cx="8549640" cy="219456"/>
+          </a:xfrm>
+          <a:prstGeom prst="rect">
+            <a:avLst/>
+          </a:prstGeom>
+          <a:noFill/>
+        </p:spPr>
+        <p:txBody>
+          <a:bodyPr wrap="square" lIns="0" rIns="0" tIns="0" bIns="0" anchor="t">
+            <a:normAutofit/>
+          </a:bodyPr>
+          <a:lstStyle/>
+          <a:p>
+            <a:pPr algn="l">
+              <a:lnSpc>
+                <a:spcPct val="100000"/>
+              </a:lnSpc>
+              <a:spcAft>
+                <a:spcPts val="103"/>
+              </a:spcAft>
+              <a:defRPr sz="860" b="0">
+                <a:solidFill>
+                  <a:srgbClr val="71808E"/>
+                </a:solidFill>
+                <a:latin typeface="Arial"/>
+              </a:defRPr>
+            </a:pPr>
+            <a:r>
+              <a:t>No era su cometido. Ahora se genera el documento que el cliente firma y el informe de avance.</a:t>
+            </a:r>
+          </a:p>
+        </p:txBody>
+      </p:sp>
+      <p:sp>
+        <p:nvSpPr>
+          <p:cNvPr id="20" name="TextBox 19"/>
+          <p:cNvSpPr txBox="1"/>
+          <p:nvPr/>
+        </p:nvSpPr>
+        <p:spPr>
+          <a:xfrm>
+            <a:off x="566928" y="3419856"/>
+            <a:ext cx="2285999" cy="274320"/>
+          </a:xfrm>
+          <a:prstGeom prst="rect">
+            <a:avLst/>
+          </a:prstGeom>
+          <a:noFill/>
+        </p:spPr>
+        <p:txBody>
+          <a:bodyPr wrap="square" lIns="0" rIns="0" tIns="0" bIns="0" anchor="ctr">
+            <a:normAutofit/>
+          </a:bodyPr>
+          <a:lstStyle/>
+          <a:p>
+            <a:pPr algn="r">
+              <a:lnSpc>
+                <a:spcPct val="100000"/>
+              </a:lnSpc>
+              <a:spcAft>
+                <a:spcPts val="126"/>
+              </a:spcAft>
+              <a:defRPr sz="1050" b="1">
+                <a:solidFill>
+                  <a:srgbClr val="17324D"/>
+                </a:solidFill>
+                <a:latin typeface="Arial"/>
+              </a:defRPr>
+            </a:pPr>
+            <a:r>
+              <a:t>Varias personas a la vez</a:t>
+            </a:r>
+          </a:p>
+        </p:txBody>
+      </p:sp>
+      <p:sp>
+        <p:nvSpPr>
+          <p:cNvPr id="21" name="Rounded Rectangle 20"/>
+          <p:cNvSpPr/>
+          <p:nvPr/>
+        </p:nvSpPr>
+        <p:spPr>
+          <a:xfrm>
+            <a:off x="3017520" y="3438144"/>
+            <a:ext cx="8549640" cy="219456"/>
+          </a:xfrm>
+          <a:prstGeom prst="roundRect">
+            <a:avLst/>
+          </a:prstGeom>
+          <a:solidFill>
+            <a:srgbClr val="E9ECEF"/>
+          </a:solidFill>
+          <a:ln w="12700">
+            <a:solidFill>
+              <a:srgbClr val="E9ECEF"/>
+            </a:solidFill>
+          </a:ln>
+        </p:spPr>
+        <p:style>
+          <a:lnRef idx="1">
+            <a:schemeClr val="accent1"/>
+          </a:lnRef>
+          <a:fillRef idx="3">
+            <a:schemeClr val="accent1"/>
+          </a:fillRef>
+          <a:effectRef idx="2">
+            <a:schemeClr val="accent1"/>
+          </a:effectRef>
+          <a:fontRef idx="minor">
+            <a:schemeClr val="lt1"/>
+          </a:fontRef>
+        </p:style>
+        <p:txBody>
+          <a:bodyPr rtlCol="0" anchor="ctr"/>
+          <a:lstStyle/>
+          <a:p>
+            <a:pPr algn="ctr"/>
+          </a:p>
+        </p:txBody>
+      </p:sp>
+      <p:sp>
+        <p:nvSpPr>
+          <p:cNvPr id="22" name="Rounded Rectangle 21"/>
+          <p:cNvSpPr/>
+          <p:nvPr/>
+        </p:nvSpPr>
+        <p:spPr>
+          <a:xfrm>
+            <a:off x="3017520" y="3438144"/>
+            <a:ext cx="3419856" cy="219456"/>
+          </a:xfrm>
+          <a:prstGeom prst="roundRect">
+            <a:avLst/>
+          </a:prstGeom>
+          <a:solidFill>
+            <a:srgbClr val="0072BC"/>
+          </a:solidFill>
+          <a:ln w="12700">
+            <a:solidFill>
+              <a:srgbClr val="0072BC"/>
+            </a:solidFill>
+          </a:ln>
+        </p:spPr>
+        <p:style>
+          <a:lnRef idx="1">
+            <a:schemeClr val="accent1"/>
+          </a:lnRef>
+          <a:fillRef idx="3">
+            <a:schemeClr val="accent1"/>
+          </a:fillRef>
+          <a:effectRef idx="2">
+            <a:schemeClr val="accent1"/>
+          </a:effectRef>
+          <a:fontRef idx="minor">
+            <a:schemeClr val="lt1"/>
+          </a:fontRef>
+        </p:style>
+        <p:txBody>
+          <a:bodyPr rtlCol="0" anchor="ctr"/>
+          <a:lstStyle/>
+          <a:p>
+            <a:pPr algn="ctr"/>
+          </a:p>
+        </p:txBody>
+      </p:sp>
+      <p:sp>
+        <p:nvSpPr>
+          <p:cNvPr id="23" name="Rounded Rectangle 22"/>
+          <p:cNvSpPr/>
+          <p:nvPr/>
+        </p:nvSpPr>
+        <p:spPr>
+          <a:xfrm>
+            <a:off x="6464808" y="3438144"/>
+            <a:ext cx="3419856" cy="219456"/>
+          </a:xfrm>
+          <a:prstGeom prst="roundRect">
+            <a:avLst/>
+          </a:prstGeom>
+          <a:solidFill>
+            <a:srgbClr val="E8792E"/>
+          </a:solidFill>
+          <a:ln w="12700">
+            <a:solidFill>
+              <a:srgbClr val="E8792E"/>
+            </a:solidFill>
+          </a:ln>
+        </p:spPr>
+        <p:style>
+          <a:lnRef idx="1">
+            <a:schemeClr val="accent1"/>
+          </a:lnRef>
+          <a:fillRef idx="3">
+            <a:schemeClr val="accent1"/>
+          </a:fillRef>
+          <a:effectRef idx="2">
+            <a:schemeClr val="accent1"/>
+          </a:effectRef>
+          <a:fontRef idx="minor">
+            <a:schemeClr val="lt1"/>
+          </a:fontRef>
+        </p:style>
+        <p:txBody>
+          <a:bodyPr rtlCol="0" anchor="ctr"/>
+          <a:lstStyle/>
+          <a:p>
+            <a:pPr algn="ctr"/>
+          </a:p>
+        </p:txBody>
+      </p:sp>
+      <p:sp>
+        <p:nvSpPr>
+          <p:cNvPr id="24" name="TextBox 23"/>
+          <p:cNvSpPr txBox="1"/>
+          <p:nvPr/>
+        </p:nvSpPr>
+        <p:spPr>
+          <a:xfrm>
+            <a:off x="3017520" y="3712463"/>
+            <a:ext cx="8549640" cy="219456"/>
+          </a:xfrm>
+          <a:prstGeom prst="rect">
+            <a:avLst/>
+          </a:prstGeom>
+          <a:noFill/>
+        </p:spPr>
+        <p:txBody>
+          <a:bodyPr wrap="square" lIns="0" rIns="0" tIns="0" bIns="0" anchor="t">
+            <a:normAutofit/>
+          </a:bodyPr>
+          <a:lstStyle/>
+          <a:p>
+            <a:pPr algn="l">
+              <a:lnSpc>
+                <a:spcPct val="100000"/>
+              </a:lnSpc>
+              <a:spcAft>
+                <a:spcPts val="103"/>
+              </a:spcAft>
+              <a:defRPr sz="860" b="0">
+                <a:solidFill>
+                  <a:srgbClr val="71808E"/>
+                </a:solidFill>
+                <a:latin typeface="Arial"/>
+              </a:defRPr>
+            </a:pPr>
+            <a:r>
+              <a:t>Ya repartía el trabajo entre varios. Ahora, además, comprueba que nadie se pise.</a:t>
+            </a:r>
+          </a:p>
+        </p:txBody>
+      </p:sp>
+      <p:sp>
+        <p:nvSpPr>
+          <p:cNvPr id="25" name="TextBox 24"/>
+          <p:cNvSpPr txBox="1"/>
+          <p:nvPr/>
+        </p:nvSpPr>
+        <p:spPr>
+          <a:xfrm>
+            <a:off x="566928" y="4041648"/>
+            <a:ext cx="2285999" cy="274320"/>
+          </a:xfrm>
+          <a:prstGeom prst="rect">
+            <a:avLst/>
+          </a:prstGeom>
+          <a:noFill/>
+        </p:spPr>
+        <p:txBody>
+          <a:bodyPr wrap="square" lIns="0" rIns="0" tIns="0" bIns="0" anchor="ctr">
+            <a:normAutofit/>
+          </a:bodyPr>
+          <a:lstStyle/>
+          <a:p>
+            <a:pPr algn="r">
+              <a:lnSpc>
+                <a:spcPct val="100000"/>
+              </a:lnSpc>
+              <a:spcAft>
+                <a:spcPts val="126"/>
+              </a:spcAft>
+              <a:defRPr sz="1050" b="1">
+                <a:solidFill>
+                  <a:srgbClr val="17324D"/>
+                </a:solidFill>
+                <a:latin typeface="Arial"/>
+              </a:defRPr>
+            </a:pPr>
+            <a:r>
+              <a:t>Saber lo que ha costado</a:t>
+            </a:r>
+          </a:p>
+        </p:txBody>
+      </p:sp>
+      <p:sp>
+        <p:nvSpPr>
+          <p:cNvPr id="26" name="Rounded Rectangle 25"/>
+          <p:cNvSpPr/>
+          <p:nvPr/>
+        </p:nvSpPr>
+        <p:spPr>
+          <a:xfrm>
+            <a:off x="3017520" y="4059936"/>
+            <a:ext cx="8549640" cy="219456"/>
+          </a:xfrm>
+          <a:prstGeom prst="roundRect">
+            <a:avLst/>
+          </a:prstGeom>
+          <a:solidFill>
+            <a:srgbClr val="E9ECEF"/>
+          </a:solidFill>
+          <a:ln w="12700">
+            <a:solidFill>
+              <a:srgbClr val="E9ECEF"/>
+            </a:solidFill>
+          </a:ln>
+        </p:spPr>
+        <p:style>
+          <a:lnRef idx="1">
+            <a:schemeClr val="accent1"/>
+          </a:lnRef>
+          <a:fillRef idx="3">
+            <a:schemeClr val="accent1"/>
+          </a:fillRef>
+          <a:effectRef idx="2">
+            <a:schemeClr val="accent1"/>
+          </a:effectRef>
+          <a:fontRef idx="minor">
+            <a:schemeClr val="lt1"/>
+          </a:fontRef>
+        </p:style>
+        <p:txBody>
+          <a:bodyPr rtlCol="0" anchor="ctr"/>
+          <a:lstStyle/>
+          <a:p>
+            <a:pPr algn="ctr"/>
+          </a:p>
+        </p:txBody>
+      </p:sp>
+      <p:sp>
+        <p:nvSpPr>
+          <p:cNvPr id="27" name="Rounded Rectangle 26"/>
+          <p:cNvSpPr/>
+          <p:nvPr/>
+        </p:nvSpPr>
+        <p:spPr>
+          <a:xfrm>
+            <a:off x="3017520" y="4059936"/>
+            <a:ext cx="4274820" cy="219456"/>
+          </a:xfrm>
+          <a:prstGeom prst="roundRect">
+            <a:avLst/>
+          </a:prstGeom>
+          <a:solidFill>
+            <a:srgbClr val="0072BC"/>
+          </a:solidFill>
+          <a:ln w="12700">
+            <a:solidFill>
+              <a:srgbClr val="0072BC"/>
+            </a:solidFill>
+          </a:ln>
+        </p:spPr>
+        <p:style>
+          <a:lnRef idx="1">
+            <a:schemeClr val="accent1"/>
+          </a:lnRef>
+          <a:fillRef idx="3">
+            <a:schemeClr val="accent1"/>
+          </a:fillRef>
+          <a:effectRef idx="2">
+            <a:schemeClr val="accent1"/>
+          </a:effectRef>
+          <a:fontRef idx="minor">
+            <a:schemeClr val="lt1"/>
+          </a:fontRef>
+        </p:style>
+        <p:txBody>
+          <a:bodyPr rtlCol="0" anchor="ctr"/>
+          <a:lstStyle/>
+          <a:p>
+            <a:pPr algn="ctr"/>
+          </a:p>
+        </p:txBody>
+      </p:sp>
+      <p:sp>
+        <p:nvSpPr>
+          <p:cNvPr id="28" name="Rounded Rectangle 27"/>
+          <p:cNvSpPr/>
+          <p:nvPr/>
+        </p:nvSpPr>
+        <p:spPr>
+          <a:xfrm>
+            <a:off x="7319771" y="4059936"/>
+            <a:ext cx="3419856" cy="219456"/>
+          </a:xfrm>
+          <a:prstGeom prst="roundRect">
+            <a:avLst/>
+          </a:prstGeom>
+          <a:solidFill>
+            <a:srgbClr val="E8792E"/>
+          </a:solidFill>
+          <a:ln w="12700">
+            <a:solidFill>
+              <a:srgbClr val="E8792E"/>
+            </a:solidFill>
+          </a:ln>
+        </p:spPr>
+        <p:style>
+          <a:lnRef idx="1">
+            <a:schemeClr val="accent1"/>
+          </a:lnRef>
+          <a:fillRef idx="3">
+            <a:schemeClr val="accent1"/>
+          </a:fillRef>
+          <a:effectRef idx="2">
+            <a:schemeClr val="accent1"/>
+          </a:effectRef>
+          <a:fontRef idx="minor">
+            <a:schemeClr val="lt1"/>
+          </a:fontRef>
+        </p:style>
+        <p:txBody>
+          <a:bodyPr rtlCol="0" anchor="ctr"/>
+          <a:lstStyle/>
+          <a:p>
+            <a:pPr algn="ctr"/>
+          </a:p>
+        </p:txBody>
+      </p:sp>
+      <p:sp>
+        <p:nvSpPr>
+          <p:cNvPr id="29" name="TextBox 28"/>
+          <p:cNvSpPr txBox="1"/>
+          <p:nvPr/>
+        </p:nvSpPr>
+        <p:spPr>
+          <a:xfrm>
+            <a:off x="3017520" y="4334256"/>
+            <a:ext cx="8549640" cy="219456"/>
+          </a:xfrm>
+          <a:prstGeom prst="rect">
+            <a:avLst/>
+          </a:prstGeom>
+          <a:noFill/>
+        </p:spPr>
+        <p:txBody>
+          <a:bodyPr wrap="square" lIns="0" rIns="0" tIns="0" bIns="0" anchor="t">
+            <a:normAutofit/>
+          </a:bodyPr>
+          <a:lstStyle/>
+          <a:p>
+            <a:pPr algn="l">
+              <a:lnSpc>
+                <a:spcPct val="100000"/>
+              </a:lnSpc>
+              <a:spcAft>
+                <a:spcPts val="103"/>
+              </a:spcAft>
+              <a:defRPr sz="860" b="0">
+                <a:solidFill>
+                  <a:srgbClr val="71808E"/>
+                </a:solidFill>
+                <a:latin typeface="Arial"/>
+              </a:defRPr>
+            </a:pPr>
+            <a:r>
+              <a:t>Él ya lo registraba todo, que es la parte difícil. Nosotros lo hemos convertido en cifras.</a:t>
+            </a:r>
+          </a:p>
+        </p:txBody>
+      </p:sp>
+      <p:sp>
+        <p:nvSpPr>
+          <p:cNvPr id="30" name="TextBox 29"/>
+          <p:cNvSpPr txBox="1"/>
+          <p:nvPr/>
+        </p:nvSpPr>
+        <p:spPr>
+          <a:xfrm>
+            <a:off x="566928" y="4663440"/>
+            <a:ext cx="2285999" cy="274320"/>
+          </a:xfrm>
+          <a:prstGeom prst="rect">
+            <a:avLst/>
+          </a:prstGeom>
+          <a:noFill/>
+        </p:spPr>
+        <p:txBody>
+          <a:bodyPr wrap="square" lIns="0" rIns="0" tIns="0" bIns="0" anchor="ctr">
+            <a:normAutofit/>
+          </a:bodyPr>
+          <a:lstStyle/>
+          <a:p>
+            <a:pPr algn="r">
+              <a:lnSpc>
+                <a:spcPct val="100000"/>
+              </a:lnSpc>
+              <a:spcAft>
+                <a:spcPts val="126"/>
+              </a:spcAft>
+              <a:defRPr sz="1050" b="1">
+                <a:solidFill>
+                  <a:srgbClr val="17324D"/>
+                </a:solidFill>
+                <a:latin typeface="Arial"/>
+              </a:defRPr>
+            </a:pPr>
+            <a:r>
+              <a:t>Encajar en el proyecto del cliente</a:t>
+            </a:r>
+          </a:p>
+        </p:txBody>
+      </p:sp>
+      <p:sp>
+        <p:nvSpPr>
+          <p:cNvPr id="31" name="Rounded Rectangle 30"/>
+          <p:cNvSpPr/>
+          <p:nvPr/>
+        </p:nvSpPr>
+        <p:spPr>
+          <a:xfrm>
+            <a:off x="3017520" y="4681728"/>
+            <a:ext cx="8549640" cy="219456"/>
+          </a:xfrm>
+          <a:prstGeom prst="roundRect">
+            <a:avLst/>
+          </a:prstGeom>
+          <a:solidFill>
+            <a:srgbClr val="E9ECEF"/>
+          </a:solidFill>
+          <a:ln w="12700">
+            <a:solidFill>
+              <a:srgbClr val="E9ECEF"/>
+            </a:solidFill>
+          </a:ln>
+        </p:spPr>
+        <p:style>
+          <a:lnRef idx="1">
+            <a:schemeClr val="accent1"/>
+          </a:lnRef>
+          <a:fillRef idx="3">
+            <a:schemeClr val="accent1"/>
+          </a:fillRef>
+          <a:effectRef idx="2">
+            <a:schemeClr val="accent1"/>
+          </a:effectRef>
+          <a:fontRef idx="minor">
+            <a:schemeClr val="lt1"/>
+          </a:fontRef>
+        </p:style>
+        <p:txBody>
+          <a:bodyPr rtlCol="0" anchor="ctr"/>
+          <a:lstStyle/>
+          <a:p>
+            <a:pPr algn="ctr"/>
+          </a:p>
+        </p:txBody>
+      </p:sp>
+      <p:sp>
+        <p:nvSpPr>
+          <p:cNvPr id="32" name="Rounded Rectangle 31"/>
+          <p:cNvSpPr/>
+          <p:nvPr/>
+        </p:nvSpPr>
+        <p:spPr>
+          <a:xfrm>
+            <a:off x="3017520" y="4681728"/>
+            <a:ext cx="2564892" cy="219456"/>
+          </a:xfrm>
+          <a:prstGeom prst="roundRect">
+            <a:avLst/>
+          </a:prstGeom>
+          <a:solidFill>
+            <a:srgbClr val="0072BC"/>
+          </a:solidFill>
+          <a:ln w="12700">
+            <a:solidFill>
+              <a:srgbClr val="0072BC"/>
+            </a:solidFill>
+          </a:ln>
+        </p:spPr>
+        <p:style>
+          <a:lnRef idx="1">
+            <a:schemeClr val="accent1"/>
+          </a:lnRef>
+          <a:fillRef idx="3">
+            <a:schemeClr val="accent1"/>
+          </a:fillRef>
+          <a:effectRef idx="2">
+            <a:schemeClr val="accent1"/>
+          </a:effectRef>
+          <a:fontRef idx="minor">
+            <a:schemeClr val="lt1"/>
+          </a:fontRef>
+        </p:style>
+        <p:txBody>
+          <a:bodyPr rtlCol="0" anchor="ctr"/>
+          <a:lstStyle/>
+          <a:p>
+            <a:pPr algn="ctr"/>
+          </a:p>
+        </p:txBody>
+      </p:sp>
+      <p:sp>
+        <p:nvSpPr>
+          <p:cNvPr id="33" name="Rounded Rectangle 32"/>
+          <p:cNvSpPr/>
+          <p:nvPr/>
+        </p:nvSpPr>
+        <p:spPr>
+          <a:xfrm>
+            <a:off x="5609844" y="4681728"/>
+            <a:ext cx="4274820" cy="219456"/>
+          </a:xfrm>
+          <a:prstGeom prst="roundRect">
+            <a:avLst/>
+          </a:prstGeom>
+          <a:solidFill>
+            <a:srgbClr val="E8792E"/>
+          </a:solidFill>
+          <a:ln w="12700">
+            <a:solidFill>
+              <a:srgbClr val="E8792E"/>
+            </a:solidFill>
+          </a:ln>
+        </p:spPr>
+        <p:style>
+          <a:lnRef idx="1">
+            <a:schemeClr val="accent1"/>
+          </a:lnRef>
+          <a:fillRef idx="3">
+            <a:schemeClr val="accent1"/>
+          </a:fillRef>
+          <a:effectRef idx="2">
+            <a:schemeClr val="accent1"/>
+          </a:effectRef>
+          <a:fontRef idx="minor">
+            <a:schemeClr val="lt1"/>
+          </a:fontRef>
+        </p:style>
+        <p:txBody>
+          <a:bodyPr rtlCol="0" anchor="ctr"/>
+          <a:lstStyle/>
+          <a:p>
+            <a:pPr algn="ctr"/>
+          </a:p>
+        </p:txBody>
+      </p:sp>
+      <p:sp>
+        <p:nvSpPr>
+          <p:cNvPr id="34" name="TextBox 33"/>
+          <p:cNvSpPr txBox="1"/>
+          <p:nvPr/>
+        </p:nvSpPr>
+        <p:spPr>
+          <a:xfrm>
+            <a:off x="3017520" y="4956048"/>
+            <a:ext cx="8549640" cy="219456"/>
+          </a:xfrm>
+          <a:prstGeom prst="rect">
+            <a:avLst/>
+          </a:prstGeom>
+          <a:noFill/>
+        </p:spPr>
+        <p:txBody>
+          <a:bodyPr wrap="square" lIns="0" rIns="0" tIns="0" bIns="0" anchor="t">
+            <a:normAutofit/>
+          </a:bodyPr>
+          <a:lstStyle/>
+          <a:p>
+            <a:pPr algn="l">
+              <a:lnSpc>
+                <a:spcPct val="100000"/>
+              </a:lnSpc>
+              <a:spcAft>
+                <a:spcPts val="103"/>
+              </a:spcAft>
+              <a:defRPr sz="860" b="0">
+                <a:solidFill>
+                  <a:srgbClr val="71808E"/>
+                </a:solidFill>
+                <a:latin typeface="Arial"/>
+              </a:defRPr>
+            </a:pPr>
+            <a:r>
+              <a:t>Pensado para un proyecto en un sitio. Ahora admite los repositorios que el cliente tenga.</a:t>
+            </a:r>
+          </a:p>
+        </p:txBody>
+      </p:sp>
+      <p:sp>
+        <p:nvSpPr>
+          <p:cNvPr id="35" name="TextBox 34"/>
+          <p:cNvSpPr txBox="1"/>
+          <p:nvPr/>
+        </p:nvSpPr>
+        <p:spPr>
+          <a:xfrm>
+            <a:off x="566928" y="5285231"/>
+            <a:ext cx="2285999" cy="274320"/>
+          </a:xfrm>
+          <a:prstGeom prst="rect">
+            <a:avLst/>
+          </a:prstGeom>
+          <a:noFill/>
+        </p:spPr>
+        <p:txBody>
+          <a:bodyPr wrap="square" lIns="0" rIns="0" tIns="0" bIns="0" anchor="ctr">
+            <a:normAutofit/>
+          </a:bodyPr>
+          <a:lstStyle/>
+          <a:p>
+            <a:pPr algn="r">
+              <a:lnSpc>
+                <a:spcPct val="100000"/>
+              </a:lnSpc>
+              <a:spcAft>
+                <a:spcPts val="126"/>
+              </a:spcAft>
+              <a:defRPr sz="1050" b="1">
+                <a:solidFill>
+                  <a:srgbClr val="17324D"/>
+                </a:solidFill>
+                <a:latin typeface="Arial"/>
+              </a:defRPr>
+            </a:pPr>
+            <a:r>
+              <a:t>Que escriba la persona</a:t>
+            </a:r>
+          </a:p>
+        </p:txBody>
+      </p:sp>
+      <p:sp>
+        <p:nvSpPr>
+          <p:cNvPr id="36" name="Rounded Rectangle 35"/>
+          <p:cNvSpPr/>
+          <p:nvPr/>
+        </p:nvSpPr>
+        <p:spPr>
+          <a:xfrm>
+            <a:off x="3017520" y="5303520"/>
+            <a:ext cx="8549640" cy="219456"/>
+          </a:xfrm>
+          <a:prstGeom prst="roundRect">
+            <a:avLst/>
+          </a:prstGeom>
+          <a:solidFill>
+            <a:srgbClr val="E9ECEF"/>
+          </a:solidFill>
+          <a:ln w="12700">
+            <a:solidFill>
+              <a:srgbClr val="E9ECEF"/>
+            </a:solidFill>
+          </a:ln>
+        </p:spPr>
+        <p:style>
+          <a:lnRef idx="1">
+            <a:schemeClr val="accent1"/>
+          </a:lnRef>
+          <a:fillRef idx="3">
+            <a:schemeClr val="accent1"/>
+          </a:fillRef>
+          <a:effectRef idx="2">
+            <a:schemeClr val="accent1"/>
+          </a:effectRef>
+          <a:fontRef idx="minor">
+            <a:schemeClr val="lt1"/>
+          </a:fontRef>
+        </p:style>
+        <p:txBody>
+          <a:bodyPr rtlCol="0" anchor="ctr"/>
+          <a:lstStyle/>
+          <a:p>
+            <a:pPr algn="ctr"/>
+          </a:p>
+        </p:txBody>
+      </p:sp>
+      <p:sp>
+        <p:nvSpPr>
+          <p:cNvPr id="37" name="Rounded Rectangle 36"/>
+          <p:cNvSpPr/>
+          <p:nvPr/>
+        </p:nvSpPr>
+        <p:spPr>
+          <a:xfrm>
+            <a:off x="3017520" y="5303520"/>
+            <a:ext cx="7523683" cy="219456"/>
+          </a:xfrm>
+          <a:prstGeom prst="roundRect">
+            <a:avLst/>
+          </a:prstGeom>
+          <a:solidFill>
+            <a:srgbClr val="E8792E"/>
+          </a:solidFill>
+          <a:ln w="12700">
+            <a:solidFill>
+              <a:srgbClr val="E8792E"/>
+            </a:solidFill>
+          </a:ln>
+        </p:spPr>
+        <p:style>
+          <a:lnRef idx="1">
+            <a:schemeClr val="accent1"/>
+          </a:lnRef>
+          <a:fillRef idx="3">
+            <a:schemeClr val="accent1"/>
+          </a:fillRef>
+          <a:effectRef idx="2">
+            <a:schemeClr val="accent1"/>
+          </a:effectRef>
+          <a:fontRef idx="minor">
+            <a:schemeClr val="lt1"/>
+          </a:fontRef>
+        </p:style>
+        <p:txBody>
+          <a:bodyPr rtlCol="0" anchor="ctr"/>
+          <a:lstStyle/>
+          <a:p>
+            <a:pPr algn="ctr"/>
+          </a:p>
+        </p:txBody>
+      </p:sp>
+      <p:sp>
+        <p:nvSpPr>
+          <p:cNvPr id="38" name="TextBox 37"/>
+          <p:cNvSpPr txBox="1"/>
+          <p:nvPr/>
+        </p:nvSpPr>
+        <p:spPr>
+          <a:xfrm>
+            <a:off x="3017520" y="5577840"/>
+            <a:ext cx="8549640" cy="219456"/>
+          </a:xfrm>
+          <a:prstGeom prst="rect">
+            <a:avLst/>
+          </a:prstGeom>
+          <a:noFill/>
+        </p:spPr>
+        <p:txBody>
+          <a:bodyPr wrap="square" lIns="0" rIns="0" tIns="0" bIns="0" anchor="t">
+            <a:normAutofit/>
+          </a:bodyPr>
+          <a:lstStyle/>
+          <a:p>
+            <a:pPr algn="l">
+              <a:lnSpc>
+                <a:spcPct val="100000"/>
+              </a:lnSpc>
+              <a:spcAft>
+                <a:spcPts val="103"/>
+              </a:spcAft>
+              <a:defRPr sz="860" b="0">
+                <a:solidFill>
+                  <a:srgbClr val="71808E"/>
+                </a:solidFill>
+                <a:latin typeface="Arial"/>
+              </a:defRPr>
+            </a:pPr>
+            <a:r>
+              <a:t>No era su planteamiento. Hoy es una opción que se elige tarea a tarea.</a:t>
+            </a:r>
+          </a:p>
+        </p:txBody>
+      </p:sp>
+      <p:sp>
+        <p:nvSpPr>
+          <p:cNvPr id="39" name="Rounded Rectangle 38"/>
+          <p:cNvSpPr/>
+          <p:nvPr/>
+        </p:nvSpPr>
+        <p:spPr>
+          <a:xfrm>
+            <a:off x="566928" y="5888736"/>
+            <a:ext cx="11064240" cy="530352"/>
           </a:xfrm>
           <a:prstGeom prst="roundRect">
             <a:avLst/>
@@ -8504,104 +9903,14 @@
       </p:sp>
       <p:sp>
         <p:nvSpPr>
-          <p:cNvPr id="8" name="Rectangle 7"/>
-          <p:cNvSpPr/>
-          <p:nvPr/>
-        </p:nvSpPr>
-        <p:spPr>
-          <a:xfrm>
-            <a:off x="566928" y="1975104"/>
-            <a:ext cx="73152" cy="1664208"/>
-          </a:xfrm>
-          <a:prstGeom prst="rect">
-            <a:avLst/>
-          </a:prstGeom>
-          <a:solidFill>
-            <a:srgbClr val="0072BC"/>
-          </a:solidFill>
-          <a:ln w="12700">
-            <a:solidFill>
-              <a:srgbClr val="0072BC"/>
-            </a:solidFill>
-          </a:ln>
-        </p:spPr>
-        <p:style>
-          <a:lnRef idx="1">
-            <a:schemeClr val="accent1"/>
-          </a:lnRef>
-          <a:fillRef idx="3">
-            <a:schemeClr val="accent1"/>
-          </a:fillRef>
-          <a:effectRef idx="2">
-            <a:schemeClr val="accent1"/>
-          </a:effectRef>
-          <a:fontRef idx="minor">
-            <a:schemeClr val="lt1"/>
-          </a:fontRef>
-        </p:style>
-        <p:txBody>
-          <a:bodyPr rtlCol="0" anchor="ctr"/>
-          <a:lstStyle/>
-          <a:p>
-            <a:pPr algn="ctr"/>
-          </a:p>
-        </p:txBody>
-      </p:sp>
-      <p:sp>
-        <p:nvSpPr>
-          <p:cNvPr id="9" name="Oval 8"/>
-          <p:cNvSpPr/>
-          <p:nvPr/>
-        </p:nvSpPr>
-        <p:spPr>
-          <a:xfrm>
-            <a:off x="877824" y="2231136"/>
-            <a:ext cx="402336" cy="402336"/>
-          </a:xfrm>
-          <a:prstGeom prst="ellipse">
-            <a:avLst/>
-          </a:prstGeom>
-          <a:solidFill>
-            <a:srgbClr val="0072BC"/>
-          </a:solidFill>
-          <a:ln>
-            <a:solidFill>
-              <a:srgbClr val="0072BC"/>
-            </a:solidFill>
-          </a:ln>
-        </p:spPr>
-        <p:style>
-          <a:lnRef idx="1">
-            <a:schemeClr val="accent1"/>
-          </a:lnRef>
-          <a:fillRef idx="3">
-            <a:schemeClr val="accent1"/>
-          </a:fillRef>
-          <a:effectRef idx="2">
-            <a:schemeClr val="accent1"/>
-          </a:effectRef>
-          <a:fontRef idx="minor">
-            <a:schemeClr val="lt1"/>
-          </a:fontRef>
-        </p:style>
-        <p:txBody>
-          <a:bodyPr rtlCol="0" anchor="ctr"/>
-          <a:lstStyle/>
-          <a:p>
-            <a:pPr algn="ctr"/>
-          </a:p>
-        </p:txBody>
-      </p:sp>
-      <p:sp>
-        <p:nvSpPr>
-          <p:cNvPr id="10" name="TextBox 9"/>
+          <p:cNvPr id="40" name="TextBox 39"/>
           <p:cNvSpPr txBox="1"/>
           <p:nvPr/>
         </p:nvSpPr>
         <p:spPr>
           <a:xfrm>
-            <a:off x="877824" y="2249424"/>
-            <a:ext cx="402336" cy="365760"/>
+            <a:off x="841248" y="5980176"/>
+            <a:ext cx="10515600" cy="347472"/>
           </a:xfrm>
           <a:prstGeom prst="rect">
             <a:avLst/>
@@ -8610,48 +9919,6 @@
         </p:spPr>
         <p:txBody>
           <a:bodyPr wrap="square" lIns="0" rIns="0" tIns="0" bIns="0" anchor="ctr">
-            <a:normAutofit/>
-          </a:bodyPr>
-          <a:lstStyle/>
-          <a:p>
-            <a:pPr algn="ctr">
-              <a:lnSpc>
-                <a:spcPct val="100000"/>
-              </a:lnSpc>
-              <a:spcAft>
-                <a:spcPts val="144"/>
-              </a:spcAft>
-              <a:defRPr sz="1200" b="1">
-                <a:solidFill>
-                  <a:srgbClr val="FFFFFF"/>
-                </a:solidFill>
-                <a:latin typeface="Arial"/>
-              </a:defRPr>
-            </a:pPr>
-            <a:r>
-              <a:t>1</a:t>
-            </a:r>
-          </a:p>
-        </p:txBody>
-      </p:sp>
-      <p:sp>
-        <p:nvSpPr>
-          <p:cNvPr id="11" name="TextBox 10"/>
-          <p:cNvSpPr txBox="1"/>
-          <p:nvPr/>
-        </p:nvSpPr>
-        <p:spPr>
-          <a:xfrm>
-            <a:off x="1499616" y="2231136"/>
-            <a:ext cx="4206240" cy="365760"/>
-          </a:xfrm>
-          <a:prstGeom prst="rect">
-            <a:avLst/>
-          </a:prstGeom>
-          <a:noFill/>
-        </p:spPr>
-        <p:txBody>
-          <a:bodyPr wrap="square" lIns="0" rIns="0" tIns="0" bIns="0" anchor="t">
             <a:normAutofit/>
           </a:bodyPr>
           <a:lstStyle/>
@@ -8661,936 +9928,24 @@
                 <a:spcPct val="100000"/>
               </a:lnSpc>
               <a:spcAft>
-                <a:spcPts val="192"/>
+                <a:spcPts val="113"/>
               </a:spcAft>
-              <a:defRPr sz="1600" b="1">
-                <a:solidFill>
-                  <a:srgbClr val="17324D"/>
+              <a:defRPr sz="950" b="0">
+                <a:solidFill>
+                  <a:srgbClr val="3F556A"/>
                 </a:solidFill>
                 <a:latin typeface="Arial"/>
               </a:defRPr>
             </a:pPr>
             <a:r>
-              <a:t>El cliente firma</a:t>
-            </a:r>
-          </a:p>
-        </p:txBody>
-      </p:sp>
-      <p:sp>
-        <p:nvSpPr>
-          <p:cNvPr id="12" name="TextBox 11"/>
-          <p:cNvSpPr txBox="1"/>
-          <p:nvPr/>
-        </p:nvSpPr>
-        <p:spPr>
-          <a:xfrm>
-            <a:off x="1499616" y="2761488"/>
-            <a:ext cx="4206240" cy="731520"/>
-          </a:xfrm>
-          <a:prstGeom prst="rect">
-            <a:avLst/>
-          </a:prstGeom>
-          <a:noFill/>
-        </p:spPr>
-        <p:txBody>
-          <a:bodyPr wrap="square" lIns="0" rIns="0" tIns="0" bIns="0" anchor="t">
-            <a:normAutofit/>
-          </a:bodyPr>
-          <a:lstStyle/>
-          <a:p>
-            <a:pPr algn="l">
-              <a:lnSpc>
-                <a:spcPct val="100000"/>
-              </a:lnSpc>
-              <a:spcAft>
-                <a:spcPts val="126"/>
-              </a:spcAft>
-              <a:defRPr sz="1050" b="0">
-                <a:solidFill>
-                  <a:srgbClr val="3F556A"/>
-                </a:solidFill>
-                <a:latin typeface="Arial"/>
-              </a:defRPr>
-            </a:pPr>
-            <a:r>
-              <a:t>El diseño funcional, el plan de pruebas y el de sprints se generan desde la misma fuente que el código. Antes se hacían a mano en Word y Excel.</a:t>
-            </a:r>
-          </a:p>
-        </p:txBody>
-      </p:sp>
-      <p:sp>
-        <p:nvSpPr>
-          <p:cNvPr id="13" name="Rounded Rectangle 12"/>
-          <p:cNvSpPr/>
-          <p:nvPr/>
-        </p:nvSpPr>
-        <p:spPr>
-          <a:xfrm>
-            <a:off x="6272784" y="1975104"/>
-            <a:ext cx="5358384" cy="1664208"/>
-          </a:xfrm>
-          <a:prstGeom prst="roundRect">
-            <a:avLst/>
-          </a:prstGeom>
-          <a:solidFill>
-            <a:srgbClr val="FFFFFF"/>
-          </a:solidFill>
-          <a:ln w="12700">
-            <a:solidFill>
-              <a:srgbClr val="D7DEE3"/>
-            </a:solidFill>
-          </a:ln>
-        </p:spPr>
-        <p:style>
-          <a:lnRef idx="1">
-            <a:schemeClr val="accent1"/>
-          </a:lnRef>
-          <a:fillRef idx="3">
-            <a:schemeClr val="accent1"/>
-          </a:fillRef>
-          <a:effectRef idx="2">
-            <a:schemeClr val="accent1"/>
-          </a:effectRef>
-          <a:fontRef idx="minor">
-            <a:schemeClr val="lt1"/>
-          </a:fontRef>
-        </p:style>
-        <p:txBody>
-          <a:bodyPr rtlCol="0" anchor="ctr"/>
-          <a:lstStyle/>
-          <a:p>
-            <a:pPr algn="ctr"/>
-          </a:p>
-        </p:txBody>
-      </p:sp>
-      <p:sp>
-        <p:nvSpPr>
-          <p:cNvPr id="14" name="Rectangle 13"/>
-          <p:cNvSpPr/>
-          <p:nvPr/>
-        </p:nvSpPr>
-        <p:spPr>
-          <a:xfrm>
-            <a:off x="6272784" y="1975104"/>
-            <a:ext cx="73152" cy="1664208"/>
-          </a:xfrm>
-          <a:prstGeom prst="rect">
-            <a:avLst/>
-          </a:prstGeom>
-          <a:solidFill>
-            <a:srgbClr val="E8792E"/>
-          </a:solidFill>
-          <a:ln w="12700">
-            <a:solidFill>
-              <a:srgbClr val="E8792E"/>
-            </a:solidFill>
-          </a:ln>
-        </p:spPr>
-        <p:style>
-          <a:lnRef idx="1">
-            <a:schemeClr val="accent1"/>
-          </a:lnRef>
-          <a:fillRef idx="3">
-            <a:schemeClr val="accent1"/>
-          </a:fillRef>
-          <a:effectRef idx="2">
-            <a:schemeClr val="accent1"/>
-          </a:effectRef>
-          <a:fontRef idx="minor">
-            <a:schemeClr val="lt1"/>
-          </a:fontRef>
-        </p:style>
-        <p:txBody>
-          <a:bodyPr rtlCol="0" anchor="ctr"/>
-          <a:lstStyle/>
-          <a:p>
-            <a:pPr algn="ctr"/>
-          </a:p>
-        </p:txBody>
-      </p:sp>
-      <p:sp>
-        <p:nvSpPr>
-          <p:cNvPr id="15" name="Oval 14"/>
-          <p:cNvSpPr/>
-          <p:nvPr/>
-        </p:nvSpPr>
-        <p:spPr>
-          <a:xfrm>
-            <a:off x="6583680" y="2231136"/>
-            <a:ext cx="402336" cy="402336"/>
-          </a:xfrm>
-          <a:prstGeom prst="ellipse">
-            <a:avLst/>
-          </a:prstGeom>
-          <a:solidFill>
-            <a:srgbClr val="E8792E"/>
-          </a:solidFill>
-          <a:ln>
-            <a:solidFill>
-              <a:srgbClr val="E8792E"/>
-            </a:solidFill>
-          </a:ln>
-        </p:spPr>
-        <p:style>
-          <a:lnRef idx="1">
-            <a:schemeClr val="accent1"/>
-          </a:lnRef>
-          <a:fillRef idx="3">
-            <a:schemeClr val="accent1"/>
-          </a:fillRef>
-          <a:effectRef idx="2">
-            <a:schemeClr val="accent1"/>
-          </a:effectRef>
-          <a:fontRef idx="minor">
-            <a:schemeClr val="lt1"/>
-          </a:fontRef>
-        </p:style>
-        <p:txBody>
-          <a:bodyPr rtlCol="0" anchor="ctr"/>
-          <a:lstStyle/>
-          <a:p>
-            <a:pPr algn="ctr"/>
-          </a:p>
-        </p:txBody>
-      </p:sp>
-      <p:sp>
-        <p:nvSpPr>
-          <p:cNvPr id="16" name="TextBox 15"/>
-          <p:cNvSpPr txBox="1"/>
-          <p:nvPr/>
-        </p:nvSpPr>
-        <p:spPr>
-          <a:xfrm>
-            <a:off x="6583680" y="2249424"/>
-            <a:ext cx="402336" cy="365760"/>
-          </a:xfrm>
-          <a:prstGeom prst="rect">
-            <a:avLst/>
-          </a:prstGeom>
-          <a:noFill/>
-        </p:spPr>
-        <p:txBody>
-          <a:bodyPr wrap="square" lIns="0" rIns="0" tIns="0" bIns="0" anchor="ctr">
-            <a:normAutofit/>
-          </a:bodyPr>
-          <a:lstStyle/>
-          <a:p>
-            <a:pPr algn="ctr">
-              <a:lnSpc>
-                <a:spcPct val="100000"/>
-              </a:lnSpc>
-              <a:spcAft>
-                <a:spcPts val="144"/>
-              </a:spcAft>
-              <a:defRPr sz="1200" b="1">
-                <a:solidFill>
-                  <a:srgbClr val="FFFFFF"/>
-                </a:solidFill>
-                <a:latin typeface="Arial"/>
-              </a:defRPr>
-            </a:pPr>
-            <a:r>
-              <a:t>2</a:t>
-            </a:r>
-          </a:p>
-        </p:txBody>
-      </p:sp>
-      <p:sp>
-        <p:nvSpPr>
-          <p:cNvPr id="17" name="TextBox 16"/>
-          <p:cNvSpPr txBox="1"/>
-          <p:nvPr/>
-        </p:nvSpPr>
-        <p:spPr>
-          <a:xfrm>
-            <a:off x="7205472" y="2231136"/>
-            <a:ext cx="4206240" cy="365760"/>
-          </a:xfrm>
-          <a:prstGeom prst="rect">
-            <a:avLst/>
-          </a:prstGeom>
-          <a:noFill/>
-        </p:spPr>
-        <p:txBody>
-          <a:bodyPr wrap="square" lIns="0" rIns="0" tIns="0" bIns="0" anchor="t">
-            <a:normAutofit/>
-          </a:bodyPr>
-          <a:lstStyle/>
-          <a:p>
-            <a:pPr algn="l">
-              <a:lnSpc>
-                <a:spcPct val="100000"/>
-              </a:lnSpc>
-              <a:spcAft>
-                <a:spcPts val="192"/>
-              </a:spcAft>
-              <a:defRPr sz="1600" b="1">
-                <a:solidFill>
-                  <a:srgbClr val="17324D"/>
-                </a:solidFill>
-                <a:latin typeface="Arial"/>
-              </a:defRPr>
-            </a:pPr>
-            <a:r>
-              <a:t>Las cifras se sostienen</a:t>
-            </a:r>
-          </a:p>
-        </p:txBody>
-      </p:sp>
-      <p:sp>
-        <p:nvSpPr>
-          <p:cNvPr id="18" name="TextBox 17"/>
-          <p:cNvSpPr txBox="1"/>
-          <p:nvPr/>
-        </p:nvSpPr>
-        <p:spPr>
-          <a:xfrm>
-            <a:off x="7205472" y="2761488"/>
-            <a:ext cx="4206240" cy="731520"/>
-          </a:xfrm>
-          <a:prstGeom prst="rect">
-            <a:avLst/>
-          </a:prstGeom>
-          <a:noFill/>
-        </p:spPr>
-        <p:txBody>
-          <a:bodyPr wrap="square" lIns="0" rIns="0" tIns="0" bIns="0" anchor="t">
-            <a:normAutofit/>
-          </a:bodyPr>
-          <a:lstStyle/>
-          <a:p>
-            <a:pPr algn="l">
-              <a:lnSpc>
-                <a:spcPct val="100000"/>
-              </a:lnSpc>
-              <a:spcAft>
-                <a:spcPts val="126"/>
-              </a:spcAft>
-              <a:defRPr sz="1050" b="0">
-                <a:solidFill>
-                  <a:srgbClr val="3F556A"/>
-                </a:solidFill>
-                <a:latin typeface="Arial"/>
-              </a:defRPr>
-            </a:pPr>
-            <a:r>
-              <a:t>Los KPIs se cruzan con el worklog real de Jira. Lo medido se distingue de lo estimado, y lo que no se sostiene no se publica.</a:t>
-            </a:r>
-          </a:p>
-        </p:txBody>
-      </p:sp>
-      <p:sp>
-        <p:nvSpPr>
-          <p:cNvPr id="19" name="Rounded Rectangle 18"/>
-          <p:cNvSpPr/>
-          <p:nvPr/>
-        </p:nvSpPr>
-        <p:spPr>
-          <a:xfrm>
-            <a:off x="566928" y="3858768"/>
-            <a:ext cx="5358384" cy="1664208"/>
-          </a:xfrm>
-          <a:prstGeom prst="roundRect">
-            <a:avLst/>
-          </a:prstGeom>
-          <a:solidFill>
-            <a:srgbClr val="FFFFFF"/>
-          </a:solidFill>
-          <a:ln w="12700">
-            <a:solidFill>
-              <a:srgbClr val="D7DEE3"/>
-            </a:solidFill>
-          </a:ln>
-        </p:spPr>
-        <p:style>
-          <a:lnRef idx="1">
-            <a:schemeClr val="accent1"/>
-          </a:lnRef>
-          <a:fillRef idx="3">
-            <a:schemeClr val="accent1"/>
-          </a:fillRef>
-          <a:effectRef idx="2">
-            <a:schemeClr val="accent1"/>
-          </a:effectRef>
-          <a:fontRef idx="minor">
-            <a:schemeClr val="lt1"/>
-          </a:fontRef>
-        </p:style>
-        <p:txBody>
-          <a:bodyPr rtlCol="0" anchor="ctr"/>
-          <a:lstStyle/>
-          <a:p>
-            <a:pPr algn="ctr"/>
-          </a:p>
-        </p:txBody>
-      </p:sp>
-      <p:sp>
-        <p:nvSpPr>
-          <p:cNvPr id="20" name="Rectangle 19"/>
-          <p:cNvSpPr/>
-          <p:nvPr/>
-        </p:nvSpPr>
-        <p:spPr>
-          <a:xfrm>
-            <a:off x="566928" y="3858768"/>
-            <a:ext cx="73152" cy="1664208"/>
-          </a:xfrm>
-          <a:prstGeom prst="rect">
-            <a:avLst/>
-          </a:prstGeom>
-          <a:solidFill>
-            <a:srgbClr val="008F83"/>
-          </a:solidFill>
-          <a:ln w="12700">
-            <a:solidFill>
-              <a:srgbClr val="008F83"/>
-            </a:solidFill>
-          </a:ln>
-        </p:spPr>
-        <p:style>
-          <a:lnRef idx="1">
-            <a:schemeClr val="accent1"/>
-          </a:lnRef>
-          <a:fillRef idx="3">
-            <a:schemeClr val="accent1"/>
-          </a:fillRef>
-          <a:effectRef idx="2">
-            <a:schemeClr val="accent1"/>
-          </a:effectRef>
-          <a:fontRef idx="minor">
-            <a:schemeClr val="lt1"/>
-          </a:fontRef>
-        </p:style>
-        <p:txBody>
-          <a:bodyPr rtlCol="0" anchor="ctr"/>
-          <a:lstStyle/>
-          <a:p>
-            <a:pPr algn="ctr"/>
-          </a:p>
-        </p:txBody>
-      </p:sp>
-      <p:sp>
-        <p:nvSpPr>
-          <p:cNvPr id="21" name="Oval 20"/>
-          <p:cNvSpPr/>
-          <p:nvPr/>
-        </p:nvSpPr>
-        <p:spPr>
-          <a:xfrm>
-            <a:off x="877824" y="4114800"/>
-            <a:ext cx="402336" cy="402336"/>
-          </a:xfrm>
-          <a:prstGeom prst="ellipse">
-            <a:avLst/>
-          </a:prstGeom>
-          <a:solidFill>
-            <a:srgbClr val="008F83"/>
-          </a:solidFill>
-          <a:ln>
-            <a:solidFill>
-              <a:srgbClr val="008F83"/>
-            </a:solidFill>
-          </a:ln>
-        </p:spPr>
-        <p:style>
-          <a:lnRef idx="1">
-            <a:schemeClr val="accent1"/>
-          </a:lnRef>
-          <a:fillRef idx="3">
-            <a:schemeClr val="accent1"/>
-          </a:fillRef>
-          <a:effectRef idx="2">
-            <a:schemeClr val="accent1"/>
-          </a:effectRef>
-          <a:fontRef idx="minor">
-            <a:schemeClr val="lt1"/>
-          </a:fontRef>
-        </p:style>
-        <p:txBody>
-          <a:bodyPr rtlCol="0" anchor="ctr"/>
-          <a:lstStyle/>
-          <a:p>
-            <a:pPr algn="ctr"/>
-          </a:p>
-        </p:txBody>
-      </p:sp>
-      <p:sp>
-        <p:nvSpPr>
-          <p:cNvPr id="22" name="TextBox 21"/>
-          <p:cNvSpPr txBox="1"/>
-          <p:nvPr/>
-        </p:nvSpPr>
-        <p:spPr>
-          <a:xfrm>
-            <a:off x="877824" y="4133088"/>
-            <a:ext cx="402336" cy="365760"/>
-          </a:xfrm>
-          <a:prstGeom prst="rect">
-            <a:avLst/>
-          </a:prstGeom>
-          <a:noFill/>
-        </p:spPr>
-        <p:txBody>
-          <a:bodyPr wrap="square" lIns="0" rIns="0" tIns="0" bIns="0" anchor="ctr">
-            <a:normAutofit/>
-          </a:bodyPr>
-          <a:lstStyle/>
-          <a:p>
-            <a:pPr algn="ctr">
-              <a:lnSpc>
-                <a:spcPct val="100000"/>
-              </a:lnSpc>
-              <a:spcAft>
-                <a:spcPts val="144"/>
-              </a:spcAft>
-              <a:defRPr sz="1200" b="1">
-                <a:solidFill>
-                  <a:srgbClr val="FFFFFF"/>
-                </a:solidFill>
-                <a:latin typeface="Arial"/>
-              </a:defRPr>
-            </a:pPr>
-            <a:r>
-              <a:t>3</a:t>
-            </a:r>
-          </a:p>
-        </p:txBody>
-      </p:sp>
-      <p:sp>
-        <p:nvSpPr>
-          <p:cNvPr id="23" name="TextBox 22"/>
-          <p:cNvSpPr txBox="1"/>
-          <p:nvPr/>
-        </p:nvSpPr>
-        <p:spPr>
-          <a:xfrm>
-            <a:off x="1499616" y="4114800"/>
-            <a:ext cx="4206240" cy="365760"/>
-          </a:xfrm>
-          <a:prstGeom prst="rect">
-            <a:avLst/>
-          </a:prstGeom>
-          <a:noFill/>
-        </p:spPr>
-        <p:txBody>
-          <a:bodyPr wrap="square" lIns="0" rIns="0" tIns="0" bIns="0" anchor="t">
-            <a:normAutofit/>
-          </a:bodyPr>
-          <a:lstStyle/>
-          <a:p>
-            <a:pPr algn="l">
-              <a:lnSpc>
-                <a:spcPct val="100000"/>
-              </a:lnSpc>
-              <a:spcAft>
-                <a:spcPts val="192"/>
-              </a:spcAft>
-              <a:defRPr sz="1600" b="1">
-                <a:solidFill>
-                  <a:srgbClr val="17324D"/>
-                </a:solidFill>
-                <a:latin typeface="Arial"/>
-              </a:defRPr>
-            </a:pPr>
-            <a:r>
-              <a:t>El método se vigila solo</a:t>
-            </a:r>
-          </a:p>
-        </p:txBody>
-      </p:sp>
-      <p:sp>
-        <p:nvSpPr>
-          <p:cNvPr id="24" name="TextBox 23"/>
-          <p:cNvSpPr txBox="1"/>
-          <p:nvPr/>
-        </p:nvSpPr>
-        <p:spPr>
-          <a:xfrm>
-            <a:off x="1499616" y="4645152"/>
-            <a:ext cx="4206240" cy="731520"/>
-          </a:xfrm>
-          <a:prstGeom prst="rect">
-            <a:avLst/>
-          </a:prstGeom>
-          <a:noFill/>
-        </p:spPr>
-        <p:txBody>
-          <a:bodyPr wrap="square" lIns="0" rIns="0" tIns="0" bIns="0" anchor="t">
-            <a:normAutofit/>
-          </a:bodyPr>
-          <a:lstStyle/>
-          <a:p>
-            <a:pPr algn="l">
-              <a:lnSpc>
-                <a:spcPct val="100000"/>
-              </a:lnSpc>
-              <a:spcAft>
-                <a:spcPts val="126"/>
-              </a:spcAft>
-              <a:defRPr sz="1050" b="0">
-                <a:solidFill>
-                  <a:srgbClr val="3F556A"/>
-                </a:solidFill>
-                <a:latin typeface="Arial"/>
-              </a:defRPr>
-            </a:pPr>
-            <a:r>
-              <a:t>Doce controles en cada cambio impiden que se degrade en silencio. Antes dependía de que alguien se acordara de revisarlo.</a:t>
-            </a:r>
-          </a:p>
-        </p:txBody>
-      </p:sp>
-      <p:sp>
-        <p:nvSpPr>
-          <p:cNvPr id="25" name="Rounded Rectangle 24"/>
-          <p:cNvSpPr/>
-          <p:nvPr/>
-        </p:nvSpPr>
-        <p:spPr>
-          <a:xfrm>
-            <a:off x="6272784" y="3858768"/>
-            <a:ext cx="5358384" cy="1664208"/>
-          </a:xfrm>
-          <a:prstGeom prst="roundRect">
-            <a:avLst/>
-          </a:prstGeom>
-          <a:solidFill>
-            <a:srgbClr val="FFFFFF"/>
-          </a:solidFill>
-          <a:ln w="12700">
-            <a:solidFill>
-              <a:srgbClr val="D7DEE3"/>
-            </a:solidFill>
-          </a:ln>
-        </p:spPr>
-        <p:style>
-          <a:lnRef idx="1">
-            <a:schemeClr val="accent1"/>
-          </a:lnRef>
-          <a:fillRef idx="3">
-            <a:schemeClr val="accent1"/>
-          </a:fillRef>
-          <a:effectRef idx="2">
-            <a:schemeClr val="accent1"/>
-          </a:effectRef>
-          <a:fontRef idx="minor">
-            <a:schemeClr val="lt1"/>
-          </a:fontRef>
-        </p:style>
-        <p:txBody>
-          <a:bodyPr rtlCol="0" anchor="ctr"/>
-          <a:lstStyle/>
-          <a:p>
-            <a:pPr algn="ctr"/>
-          </a:p>
-        </p:txBody>
-      </p:sp>
-      <p:sp>
-        <p:nvSpPr>
-          <p:cNvPr id="26" name="Rectangle 25"/>
-          <p:cNvSpPr/>
-          <p:nvPr/>
-        </p:nvSpPr>
-        <p:spPr>
-          <a:xfrm>
-            <a:off x="6272784" y="3858768"/>
-            <a:ext cx="73152" cy="1664208"/>
-          </a:xfrm>
-          <a:prstGeom prst="rect">
-            <a:avLst/>
-          </a:prstGeom>
-          <a:solidFill>
-            <a:srgbClr val="16A9C7"/>
-          </a:solidFill>
-          <a:ln w="12700">
-            <a:solidFill>
-              <a:srgbClr val="16A9C7"/>
-            </a:solidFill>
-          </a:ln>
-        </p:spPr>
-        <p:style>
-          <a:lnRef idx="1">
-            <a:schemeClr val="accent1"/>
-          </a:lnRef>
-          <a:fillRef idx="3">
-            <a:schemeClr val="accent1"/>
-          </a:fillRef>
-          <a:effectRef idx="2">
-            <a:schemeClr val="accent1"/>
-          </a:effectRef>
-          <a:fontRef idx="minor">
-            <a:schemeClr val="lt1"/>
-          </a:fontRef>
-        </p:style>
-        <p:txBody>
-          <a:bodyPr rtlCol="0" anchor="ctr"/>
-          <a:lstStyle/>
-          <a:p>
-            <a:pPr algn="ctr"/>
-          </a:p>
-        </p:txBody>
-      </p:sp>
-      <p:sp>
-        <p:nvSpPr>
-          <p:cNvPr id="27" name="Oval 26"/>
-          <p:cNvSpPr/>
-          <p:nvPr/>
-        </p:nvSpPr>
-        <p:spPr>
-          <a:xfrm>
-            <a:off x="6583680" y="4114800"/>
-            <a:ext cx="402336" cy="402336"/>
-          </a:xfrm>
-          <a:prstGeom prst="ellipse">
-            <a:avLst/>
-          </a:prstGeom>
-          <a:solidFill>
-            <a:srgbClr val="16A9C7"/>
-          </a:solidFill>
-          <a:ln>
-            <a:solidFill>
-              <a:srgbClr val="16A9C7"/>
-            </a:solidFill>
-          </a:ln>
-        </p:spPr>
-        <p:style>
-          <a:lnRef idx="1">
-            <a:schemeClr val="accent1"/>
-          </a:lnRef>
-          <a:fillRef idx="3">
-            <a:schemeClr val="accent1"/>
-          </a:fillRef>
-          <a:effectRef idx="2">
-            <a:schemeClr val="accent1"/>
-          </a:effectRef>
-          <a:fontRef idx="minor">
-            <a:schemeClr val="lt1"/>
-          </a:fontRef>
-        </p:style>
-        <p:txBody>
-          <a:bodyPr rtlCol="0" anchor="ctr"/>
-          <a:lstStyle/>
-          <a:p>
-            <a:pPr algn="ctr"/>
-          </a:p>
-        </p:txBody>
-      </p:sp>
-      <p:sp>
-        <p:nvSpPr>
-          <p:cNvPr id="28" name="TextBox 27"/>
-          <p:cNvSpPr txBox="1"/>
-          <p:nvPr/>
-        </p:nvSpPr>
-        <p:spPr>
-          <a:xfrm>
-            <a:off x="6583680" y="4133088"/>
-            <a:ext cx="402336" cy="365760"/>
-          </a:xfrm>
-          <a:prstGeom prst="rect">
-            <a:avLst/>
-          </a:prstGeom>
-          <a:noFill/>
-        </p:spPr>
-        <p:txBody>
-          <a:bodyPr wrap="square" lIns="0" rIns="0" tIns="0" bIns="0" anchor="ctr">
-            <a:normAutofit/>
-          </a:bodyPr>
-          <a:lstStyle/>
-          <a:p>
-            <a:pPr algn="ctr">
-              <a:lnSpc>
-                <a:spcPct val="100000"/>
-              </a:lnSpc>
-              <a:spcAft>
-                <a:spcPts val="144"/>
-              </a:spcAft>
-              <a:defRPr sz="1200" b="1">
-                <a:solidFill>
-                  <a:srgbClr val="FFFFFF"/>
-                </a:solidFill>
-                <a:latin typeface="Arial"/>
-              </a:defRPr>
-            </a:pPr>
-            <a:r>
-              <a:t>4</a:t>
-            </a:r>
-          </a:p>
-        </p:txBody>
-      </p:sp>
-      <p:sp>
-        <p:nvSpPr>
-          <p:cNvPr id="29" name="TextBox 28"/>
-          <p:cNvSpPr txBox="1"/>
-          <p:nvPr/>
-        </p:nvSpPr>
-        <p:spPr>
-          <a:xfrm>
-            <a:off x="7205472" y="4114800"/>
-            <a:ext cx="4206240" cy="365760"/>
-          </a:xfrm>
-          <a:prstGeom prst="rect">
-            <a:avLst/>
-          </a:prstGeom>
-          <a:noFill/>
-        </p:spPr>
-        <p:txBody>
-          <a:bodyPr wrap="square" lIns="0" rIns="0" tIns="0" bIns="0" anchor="t">
-            <a:normAutofit/>
-          </a:bodyPr>
-          <a:lstStyle/>
-          <a:p>
-            <a:pPr algn="l">
-              <a:lnSpc>
-                <a:spcPct val="100000"/>
-              </a:lnSpc>
-              <a:spcAft>
-                <a:spcPts val="192"/>
-              </a:spcAft>
-              <a:defRPr sz="1600" b="1">
-                <a:solidFill>
-                  <a:srgbClr val="17324D"/>
-                </a:solidFill>
-                <a:latin typeface="Arial"/>
-              </a:defRPr>
-            </a:pPr>
-            <a:r>
-              <a:t>Escala sin reescribirse</a:t>
-            </a:r>
-          </a:p>
-        </p:txBody>
-      </p:sp>
-      <p:sp>
-        <p:nvSpPr>
-          <p:cNvPr id="30" name="TextBox 29"/>
-          <p:cNvSpPr txBox="1"/>
-          <p:nvPr/>
-        </p:nvSpPr>
-        <p:spPr>
-          <a:xfrm>
-            <a:off x="7205472" y="4645152"/>
-            <a:ext cx="4206240" cy="731520"/>
-          </a:xfrm>
-          <a:prstGeom prst="rect">
-            <a:avLst/>
-          </a:prstGeom>
-          <a:noFill/>
-        </p:spPr>
-        <p:txBody>
-          <a:bodyPr wrap="square" lIns="0" rIns="0" tIns="0" bIns="0" anchor="t">
-            <a:normAutofit/>
-          </a:bodyPr>
-          <a:lstStyle/>
-          <a:p>
-            <a:pPr algn="l">
-              <a:lnSpc>
-                <a:spcPct val="100000"/>
-              </a:lnSpc>
-              <a:spcAft>
-                <a:spcPts val="126"/>
-              </a:spcAft>
-              <a:defRPr sz="1050" b="0">
-                <a:solidFill>
-                  <a:srgbClr val="3F556A"/>
-                </a:solidFill>
-                <a:latin typeface="Arial"/>
-              </a:defRPr>
-            </a:pPr>
-            <a:r>
-              <a:t>Funciona con uno o con varios repositorios, con varias personas a la vez y en tres herramientas distintas de IA.</a:t>
-            </a:r>
-          </a:p>
-        </p:txBody>
-      </p:sp>
-      <p:sp>
-        <p:nvSpPr>
-          <p:cNvPr id="31" name="Rounded Rectangle 30"/>
-          <p:cNvSpPr/>
-          <p:nvPr/>
-        </p:nvSpPr>
-        <p:spPr>
-          <a:xfrm>
-            <a:off x="566928" y="5797296"/>
-            <a:ext cx="11064240" cy="548640"/>
-          </a:xfrm>
-          <a:prstGeom prst="roundRect">
-            <a:avLst/>
-          </a:prstGeom>
-          <a:solidFill>
-            <a:srgbClr val="FCE9DC"/>
-          </a:solidFill>
-          <a:ln w="12700">
-            <a:solidFill>
-              <a:srgbClr val="FCE9DC"/>
-            </a:solidFill>
-          </a:ln>
-        </p:spPr>
-        <p:style>
-          <a:lnRef idx="1">
-            <a:schemeClr val="accent1"/>
-          </a:lnRef>
-          <a:fillRef idx="3">
-            <a:schemeClr val="accent1"/>
-          </a:fillRef>
-          <a:effectRef idx="2">
-            <a:schemeClr val="accent1"/>
-          </a:effectRef>
-          <a:fontRef idx="minor">
-            <a:schemeClr val="lt1"/>
-          </a:fontRef>
-        </p:style>
-        <p:txBody>
-          <a:bodyPr rtlCol="0" anchor="ctr"/>
-          <a:lstStyle/>
-          <a:p>
-            <a:pPr algn="ctr"/>
-          </a:p>
-        </p:txBody>
-      </p:sp>
-      <p:sp>
-        <p:nvSpPr>
-          <p:cNvPr id="32" name="TextBox 31"/>
-          <p:cNvSpPr txBox="1"/>
-          <p:nvPr/>
-        </p:nvSpPr>
-        <p:spPr>
-          <a:xfrm>
-            <a:off x="841248" y="5907024"/>
-            <a:ext cx="10515600" cy="310896"/>
-          </a:xfrm>
-          <a:prstGeom prst="rect">
-            <a:avLst/>
-          </a:prstGeom>
-          <a:noFill/>
-        </p:spPr>
-        <p:txBody>
-          <a:bodyPr wrap="square" lIns="0" rIns="0" tIns="0" bIns="0" anchor="ctr">
-            <a:normAutofit/>
-          </a:bodyPr>
-          <a:lstStyle/>
-          <a:p>
-            <a:pPr algn="ctr">
-              <a:lnSpc>
-                <a:spcPct val="100000"/>
-              </a:lnSpc>
-              <a:spcAft>
-                <a:spcPts val="144"/>
-              </a:spcAft>
-              <a:defRPr sz="1200" b="1">
-                <a:solidFill>
-                  <a:srgbClr val="17324D"/>
-                </a:solidFill>
-                <a:latin typeface="Arial"/>
-              </a:defRPr>
-            </a:pPr>
-            <a:r>
-              <a:t>En una línea  ·  El método sabía construir software sin desviarse de lo pedido. Ahora también sabe demostrarlo.</a:t>
-            </a:r>
-          </a:p>
-        </p:txBody>
-      </p:sp>
-      <p:sp>
-        <p:nvSpPr>
-          <p:cNvPr id="33" name="TextBox 32"/>
+              <a:t>Valoración del equipo, no una medición: lo que cuenta es el tramo ámbar. Donde no hay tramo azul no es que el método fallara, es que eso no entraba en lo que se propuso resolver.</a:t>
+            </a:r>
+          </a:p>
+        </p:txBody>
+      </p:sp>
+      <p:sp>
+        <p:nvSpPr>
+          <p:cNvPr id="41" name="TextBox 40"/>
           <p:cNvSpPr txBox="1"/>
           <p:nvPr/>
         </p:nvSpPr>
@@ -9632,7 +9987,7 @@
       </p:sp>
       <p:sp>
         <p:nvSpPr>
-          <p:cNvPr id="34" name="TextBox 33"/>
+          <p:cNvPr id="42" name="TextBox 41"/>
           <p:cNvSpPr txBox="1"/>
           <p:nvPr/>
         </p:nvSpPr>
@@ -9667,7 +10022,7 @@
               </a:defRPr>
             </a:pPr>
             <a:r>
-              <a:t>04 / 05</a:t>
+              <a:t>04 / 06</a:t>
             </a:r>
           </a:p>
         </p:txBody>
@@ -9772,7 +10127,7 @@
               </a:defRPr>
             </a:pPr>
             <a:r>
-              <a:t>DÓNDE ESTAMOS</a:t>
+              <a:t>LO QUE CAMBIA</a:t>
             </a:r>
           </a:p>
         </p:txBody>
@@ -9814,7 +10169,7 @@
               </a:defRPr>
             </a:pPr>
             <a:r>
-              <a:t>Está en uso, se instala en un comando y sigue creciendo</a:t>
+              <a:t>Cuatro cosas que antes no podíamos hacer delante de un cliente</a:t>
             </a:r>
           </a:p>
         </p:txBody>
@@ -9856,7 +10211,7 @@
               </a:defRPr>
             </a:pPr>
             <a:r>
-              <a:t>No es un piloto ni una prueba de concepto: está publicado, versionado y funcionando en proyecto.</a:t>
+              <a:t>El método terminaba en el código validado. Ahora llega hasta lo que el cliente firma y la cifra con la que nos juzga.</a:t>
             </a:r>
           </a:p>
         </p:txBody>
@@ -9912,8 +10267,8 @@
         </p:nvSpPr>
         <p:spPr>
           <a:xfrm>
-            <a:off x="566928" y="1956816"/>
-            <a:ext cx="3529584" cy="2048256"/>
+            <a:off x="566928" y="1975104"/>
+            <a:ext cx="5358384" cy="1664208"/>
           </a:xfrm>
           <a:prstGeom prst="roundRect">
             <a:avLst/>
@@ -9957,8 +10312,530 @@
         </p:nvSpPr>
         <p:spPr>
           <a:xfrm>
-            <a:off x="566928" y="1956816"/>
-            <a:ext cx="3529584" cy="73152"/>
+            <a:off x="566928" y="1975104"/>
+            <a:ext cx="73152" cy="1664208"/>
+          </a:xfrm>
+          <a:prstGeom prst="rect">
+            <a:avLst/>
+          </a:prstGeom>
+          <a:solidFill>
+            <a:srgbClr val="0072BC"/>
+          </a:solidFill>
+          <a:ln w="12700">
+            <a:solidFill>
+              <a:srgbClr val="0072BC"/>
+            </a:solidFill>
+          </a:ln>
+        </p:spPr>
+        <p:style>
+          <a:lnRef idx="1">
+            <a:schemeClr val="accent1"/>
+          </a:lnRef>
+          <a:fillRef idx="3">
+            <a:schemeClr val="accent1"/>
+          </a:fillRef>
+          <a:effectRef idx="2">
+            <a:schemeClr val="accent1"/>
+          </a:effectRef>
+          <a:fontRef idx="minor">
+            <a:schemeClr val="lt1"/>
+          </a:fontRef>
+        </p:style>
+        <p:txBody>
+          <a:bodyPr rtlCol="0" anchor="ctr"/>
+          <a:lstStyle/>
+          <a:p>
+            <a:pPr algn="ctr"/>
+          </a:p>
+        </p:txBody>
+      </p:sp>
+      <p:sp>
+        <p:nvSpPr>
+          <p:cNvPr id="9" name="Oval 8"/>
+          <p:cNvSpPr/>
+          <p:nvPr/>
+        </p:nvSpPr>
+        <p:spPr>
+          <a:xfrm>
+            <a:off x="877824" y="2231136"/>
+            <a:ext cx="402336" cy="402336"/>
+          </a:xfrm>
+          <a:prstGeom prst="ellipse">
+            <a:avLst/>
+          </a:prstGeom>
+          <a:solidFill>
+            <a:srgbClr val="0072BC"/>
+          </a:solidFill>
+          <a:ln>
+            <a:solidFill>
+              <a:srgbClr val="0072BC"/>
+            </a:solidFill>
+          </a:ln>
+        </p:spPr>
+        <p:style>
+          <a:lnRef idx="1">
+            <a:schemeClr val="accent1"/>
+          </a:lnRef>
+          <a:fillRef idx="3">
+            <a:schemeClr val="accent1"/>
+          </a:fillRef>
+          <a:effectRef idx="2">
+            <a:schemeClr val="accent1"/>
+          </a:effectRef>
+          <a:fontRef idx="minor">
+            <a:schemeClr val="lt1"/>
+          </a:fontRef>
+        </p:style>
+        <p:txBody>
+          <a:bodyPr rtlCol="0" anchor="ctr"/>
+          <a:lstStyle/>
+          <a:p>
+            <a:pPr algn="ctr"/>
+          </a:p>
+        </p:txBody>
+      </p:sp>
+      <p:sp>
+        <p:nvSpPr>
+          <p:cNvPr id="10" name="TextBox 9"/>
+          <p:cNvSpPr txBox="1"/>
+          <p:nvPr/>
+        </p:nvSpPr>
+        <p:spPr>
+          <a:xfrm>
+            <a:off x="877824" y="2249424"/>
+            <a:ext cx="402336" cy="365760"/>
+          </a:xfrm>
+          <a:prstGeom prst="rect">
+            <a:avLst/>
+          </a:prstGeom>
+          <a:noFill/>
+        </p:spPr>
+        <p:txBody>
+          <a:bodyPr wrap="square" lIns="0" rIns="0" tIns="0" bIns="0" anchor="ctr">
+            <a:normAutofit/>
+          </a:bodyPr>
+          <a:lstStyle/>
+          <a:p>
+            <a:pPr algn="ctr">
+              <a:lnSpc>
+                <a:spcPct val="100000"/>
+              </a:lnSpc>
+              <a:spcAft>
+                <a:spcPts val="144"/>
+              </a:spcAft>
+              <a:defRPr sz="1200" b="1">
+                <a:solidFill>
+                  <a:srgbClr val="FFFFFF"/>
+                </a:solidFill>
+                <a:latin typeface="Arial"/>
+              </a:defRPr>
+            </a:pPr>
+            <a:r>
+              <a:t>1</a:t>
+            </a:r>
+          </a:p>
+        </p:txBody>
+      </p:sp>
+      <p:sp>
+        <p:nvSpPr>
+          <p:cNvPr id="11" name="TextBox 10"/>
+          <p:cNvSpPr txBox="1"/>
+          <p:nvPr/>
+        </p:nvSpPr>
+        <p:spPr>
+          <a:xfrm>
+            <a:off x="1499616" y="2231136"/>
+            <a:ext cx="4206240" cy="365760"/>
+          </a:xfrm>
+          <a:prstGeom prst="rect">
+            <a:avLst/>
+          </a:prstGeom>
+          <a:noFill/>
+        </p:spPr>
+        <p:txBody>
+          <a:bodyPr wrap="square" lIns="0" rIns="0" tIns="0" bIns="0" anchor="t">
+            <a:normAutofit/>
+          </a:bodyPr>
+          <a:lstStyle/>
+          <a:p>
+            <a:pPr algn="l">
+              <a:lnSpc>
+                <a:spcPct val="100000"/>
+              </a:lnSpc>
+              <a:spcAft>
+                <a:spcPts val="192"/>
+              </a:spcAft>
+              <a:defRPr sz="1600" b="1">
+                <a:solidFill>
+                  <a:srgbClr val="17324D"/>
+                </a:solidFill>
+                <a:latin typeface="Arial"/>
+              </a:defRPr>
+            </a:pPr>
+            <a:r>
+              <a:t>El cliente firma</a:t>
+            </a:r>
+          </a:p>
+        </p:txBody>
+      </p:sp>
+      <p:sp>
+        <p:nvSpPr>
+          <p:cNvPr id="12" name="TextBox 11"/>
+          <p:cNvSpPr txBox="1"/>
+          <p:nvPr/>
+        </p:nvSpPr>
+        <p:spPr>
+          <a:xfrm>
+            <a:off x="1499616" y="2761488"/>
+            <a:ext cx="4206240" cy="731520"/>
+          </a:xfrm>
+          <a:prstGeom prst="rect">
+            <a:avLst/>
+          </a:prstGeom>
+          <a:noFill/>
+        </p:spPr>
+        <p:txBody>
+          <a:bodyPr wrap="square" lIns="0" rIns="0" tIns="0" bIns="0" anchor="t">
+            <a:normAutofit/>
+          </a:bodyPr>
+          <a:lstStyle/>
+          <a:p>
+            <a:pPr algn="l">
+              <a:lnSpc>
+                <a:spcPct val="100000"/>
+              </a:lnSpc>
+              <a:spcAft>
+                <a:spcPts val="126"/>
+              </a:spcAft>
+              <a:defRPr sz="1050" b="0">
+                <a:solidFill>
+                  <a:srgbClr val="3F556A"/>
+                </a:solidFill>
+                <a:latin typeface="Arial"/>
+              </a:defRPr>
+            </a:pPr>
+            <a:r>
+              <a:t>El diseño funcional, el plan de pruebas y el de sprints se generan desde la misma fuente que el código. Antes se hacían a mano en Word y Excel.</a:t>
+            </a:r>
+          </a:p>
+        </p:txBody>
+      </p:sp>
+      <p:sp>
+        <p:nvSpPr>
+          <p:cNvPr id="13" name="Rounded Rectangle 12"/>
+          <p:cNvSpPr/>
+          <p:nvPr/>
+        </p:nvSpPr>
+        <p:spPr>
+          <a:xfrm>
+            <a:off x="6272784" y="1975104"/>
+            <a:ext cx="5358384" cy="1664208"/>
+          </a:xfrm>
+          <a:prstGeom prst="roundRect">
+            <a:avLst/>
+          </a:prstGeom>
+          <a:solidFill>
+            <a:srgbClr val="FFFFFF"/>
+          </a:solidFill>
+          <a:ln w="12700">
+            <a:solidFill>
+              <a:srgbClr val="D7DEE3"/>
+            </a:solidFill>
+          </a:ln>
+        </p:spPr>
+        <p:style>
+          <a:lnRef idx="1">
+            <a:schemeClr val="accent1"/>
+          </a:lnRef>
+          <a:fillRef idx="3">
+            <a:schemeClr val="accent1"/>
+          </a:fillRef>
+          <a:effectRef idx="2">
+            <a:schemeClr val="accent1"/>
+          </a:effectRef>
+          <a:fontRef idx="minor">
+            <a:schemeClr val="lt1"/>
+          </a:fontRef>
+        </p:style>
+        <p:txBody>
+          <a:bodyPr rtlCol="0" anchor="ctr"/>
+          <a:lstStyle/>
+          <a:p>
+            <a:pPr algn="ctr"/>
+          </a:p>
+        </p:txBody>
+      </p:sp>
+      <p:sp>
+        <p:nvSpPr>
+          <p:cNvPr id="14" name="Rectangle 13"/>
+          <p:cNvSpPr/>
+          <p:nvPr/>
+        </p:nvSpPr>
+        <p:spPr>
+          <a:xfrm>
+            <a:off x="6272784" y="1975104"/>
+            <a:ext cx="73152" cy="1664208"/>
+          </a:xfrm>
+          <a:prstGeom prst="rect">
+            <a:avLst/>
+          </a:prstGeom>
+          <a:solidFill>
+            <a:srgbClr val="E8792E"/>
+          </a:solidFill>
+          <a:ln w="12700">
+            <a:solidFill>
+              <a:srgbClr val="E8792E"/>
+            </a:solidFill>
+          </a:ln>
+        </p:spPr>
+        <p:style>
+          <a:lnRef idx="1">
+            <a:schemeClr val="accent1"/>
+          </a:lnRef>
+          <a:fillRef idx="3">
+            <a:schemeClr val="accent1"/>
+          </a:fillRef>
+          <a:effectRef idx="2">
+            <a:schemeClr val="accent1"/>
+          </a:effectRef>
+          <a:fontRef idx="minor">
+            <a:schemeClr val="lt1"/>
+          </a:fontRef>
+        </p:style>
+        <p:txBody>
+          <a:bodyPr rtlCol="0" anchor="ctr"/>
+          <a:lstStyle/>
+          <a:p>
+            <a:pPr algn="ctr"/>
+          </a:p>
+        </p:txBody>
+      </p:sp>
+      <p:sp>
+        <p:nvSpPr>
+          <p:cNvPr id="15" name="Oval 14"/>
+          <p:cNvSpPr/>
+          <p:nvPr/>
+        </p:nvSpPr>
+        <p:spPr>
+          <a:xfrm>
+            <a:off x="6583680" y="2231136"/>
+            <a:ext cx="402336" cy="402336"/>
+          </a:xfrm>
+          <a:prstGeom prst="ellipse">
+            <a:avLst/>
+          </a:prstGeom>
+          <a:solidFill>
+            <a:srgbClr val="E8792E"/>
+          </a:solidFill>
+          <a:ln>
+            <a:solidFill>
+              <a:srgbClr val="E8792E"/>
+            </a:solidFill>
+          </a:ln>
+        </p:spPr>
+        <p:style>
+          <a:lnRef idx="1">
+            <a:schemeClr val="accent1"/>
+          </a:lnRef>
+          <a:fillRef idx="3">
+            <a:schemeClr val="accent1"/>
+          </a:fillRef>
+          <a:effectRef idx="2">
+            <a:schemeClr val="accent1"/>
+          </a:effectRef>
+          <a:fontRef idx="minor">
+            <a:schemeClr val="lt1"/>
+          </a:fontRef>
+        </p:style>
+        <p:txBody>
+          <a:bodyPr rtlCol="0" anchor="ctr"/>
+          <a:lstStyle/>
+          <a:p>
+            <a:pPr algn="ctr"/>
+          </a:p>
+        </p:txBody>
+      </p:sp>
+      <p:sp>
+        <p:nvSpPr>
+          <p:cNvPr id="16" name="TextBox 15"/>
+          <p:cNvSpPr txBox="1"/>
+          <p:nvPr/>
+        </p:nvSpPr>
+        <p:spPr>
+          <a:xfrm>
+            <a:off x="6583680" y="2249424"/>
+            <a:ext cx="402336" cy="365760"/>
+          </a:xfrm>
+          <a:prstGeom prst="rect">
+            <a:avLst/>
+          </a:prstGeom>
+          <a:noFill/>
+        </p:spPr>
+        <p:txBody>
+          <a:bodyPr wrap="square" lIns="0" rIns="0" tIns="0" bIns="0" anchor="ctr">
+            <a:normAutofit/>
+          </a:bodyPr>
+          <a:lstStyle/>
+          <a:p>
+            <a:pPr algn="ctr">
+              <a:lnSpc>
+                <a:spcPct val="100000"/>
+              </a:lnSpc>
+              <a:spcAft>
+                <a:spcPts val="144"/>
+              </a:spcAft>
+              <a:defRPr sz="1200" b="1">
+                <a:solidFill>
+                  <a:srgbClr val="FFFFFF"/>
+                </a:solidFill>
+                <a:latin typeface="Arial"/>
+              </a:defRPr>
+            </a:pPr>
+            <a:r>
+              <a:t>2</a:t>
+            </a:r>
+          </a:p>
+        </p:txBody>
+      </p:sp>
+      <p:sp>
+        <p:nvSpPr>
+          <p:cNvPr id="17" name="TextBox 16"/>
+          <p:cNvSpPr txBox="1"/>
+          <p:nvPr/>
+        </p:nvSpPr>
+        <p:spPr>
+          <a:xfrm>
+            <a:off x="7205472" y="2231136"/>
+            <a:ext cx="4206240" cy="365760"/>
+          </a:xfrm>
+          <a:prstGeom prst="rect">
+            <a:avLst/>
+          </a:prstGeom>
+          <a:noFill/>
+        </p:spPr>
+        <p:txBody>
+          <a:bodyPr wrap="square" lIns="0" rIns="0" tIns="0" bIns="0" anchor="t">
+            <a:normAutofit/>
+          </a:bodyPr>
+          <a:lstStyle/>
+          <a:p>
+            <a:pPr algn="l">
+              <a:lnSpc>
+                <a:spcPct val="100000"/>
+              </a:lnSpc>
+              <a:spcAft>
+                <a:spcPts val="192"/>
+              </a:spcAft>
+              <a:defRPr sz="1600" b="1">
+                <a:solidFill>
+                  <a:srgbClr val="17324D"/>
+                </a:solidFill>
+                <a:latin typeface="Arial"/>
+              </a:defRPr>
+            </a:pPr>
+            <a:r>
+              <a:t>Las cifras se sostienen</a:t>
+            </a:r>
+          </a:p>
+        </p:txBody>
+      </p:sp>
+      <p:sp>
+        <p:nvSpPr>
+          <p:cNvPr id="18" name="TextBox 17"/>
+          <p:cNvSpPr txBox="1"/>
+          <p:nvPr/>
+        </p:nvSpPr>
+        <p:spPr>
+          <a:xfrm>
+            <a:off x="7205472" y="2761488"/>
+            <a:ext cx="4206240" cy="731520"/>
+          </a:xfrm>
+          <a:prstGeom prst="rect">
+            <a:avLst/>
+          </a:prstGeom>
+          <a:noFill/>
+        </p:spPr>
+        <p:txBody>
+          <a:bodyPr wrap="square" lIns="0" rIns="0" tIns="0" bIns="0" anchor="t">
+            <a:normAutofit/>
+          </a:bodyPr>
+          <a:lstStyle/>
+          <a:p>
+            <a:pPr algn="l">
+              <a:lnSpc>
+                <a:spcPct val="100000"/>
+              </a:lnSpc>
+              <a:spcAft>
+                <a:spcPts val="126"/>
+              </a:spcAft>
+              <a:defRPr sz="1050" b="0">
+                <a:solidFill>
+                  <a:srgbClr val="3F556A"/>
+                </a:solidFill>
+                <a:latin typeface="Arial"/>
+              </a:defRPr>
+            </a:pPr>
+            <a:r>
+              <a:t>Los KPIs se cruzan con el worklog real de Jira. Lo medido se distingue de lo estimado, y lo que no se sostiene no se publica.</a:t>
+            </a:r>
+          </a:p>
+        </p:txBody>
+      </p:sp>
+      <p:sp>
+        <p:nvSpPr>
+          <p:cNvPr id="19" name="Rounded Rectangle 18"/>
+          <p:cNvSpPr/>
+          <p:nvPr/>
+        </p:nvSpPr>
+        <p:spPr>
+          <a:xfrm>
+            <a:off x="566928" y="3858768"/>
+            <a:ext cx="5358384" cy="1664208"/>
+          </a:xfrm>
+          <a:prstGeom prst="roundRect">
+            <a:avLst/>
+          </a:prstGeom>
+          <a:solidFill>
+            <a:srgbClr val="FFFFFF"/>
+          </a:solidFill>
+          <a:ln w="12700">
+            <a:solidFill>
+              <a:srgbClr val="D7DEE3"/>
+            </a:solidFill>
+          </a:ln>
+        </p:spPr>
+        <p:style>
+          <a:lnRef idx="1">
+            <a:schemeClr val="accent1"/>
+          </a:lnRef>
+          <a:fillRef idx="3">
+            <a:schemeClr val="accent1"/>
+          </a:fillRef>
+          <a:effectRef idx="2">
+            <a:schemeClr val="accent1"/>
+          </a:effectRef>
+          <a:fontRef idx="minor">
+            <a:schemeClr val="lt1"/>
+          </a:fontRef>
+        </p:style>
+        <p:txBody>
+          <a:bodyPr rtlCol="0" anchor="ctr"/>
+          <a:lstStyle/>
+          <a:p>
+            <a:pPr algn="ctr"/>
+          </a:p>
+        </p:txBody>
+      </p:sp>
+      <p:sp>
+        <p:nvSpPr>
+          <p:cNvPr id="20" name="Rectangle 19"/>
+          <p:cNvSpPr/>
+          <p:nvPr/>
+        </p:nvSpPr>
+        <p:spPr>
+          <a:xfrm>
+            <a:off x="566928" y="3858768"/>
+            <a:ext cx="73152" cy="1664208"/>
           </a:xfrm>
           <a:prstGeom prst="rect">
             <a:avLst/>
@@ -9996,14 +10873,680 @@
       </p:sp>
       <p:sp>
         <p:nvSpPr>
-          <p:cNvPr id="9" name="TextBox 8"/>
+          <p:cNvPr id="21" name="Oval 20"/>
+          <p:cNvSpPr/>
+          <p:nvPr/>
+        </p:nvSpPr>
+        <p:spPr>
+          <a:xfrm>
+            <a:off x="877824" y="4114800"/>
+            <a:ext cx="402336" cy="402336"/>
+          </a:xfrm>
+          <a:prstGeom prst="ellipse">
+            <a:avLst/>
+          </a:prstGeom>
+          <a:solidFill>
+            <a:srgbClr val="008F83"/>
+          </a:solidFill>
+          <a:ln>
+            <a:solidFill>
+              <a:srgbClr val="008F83"/>
+            </a:solidFill>
+          </a:ln>
+        </p:spPr>
+        <p:style>
+          <a:lnRef idx="1">
+            <a:schemeClr val="accent1"/>
+          </a:lnRef>
+          <a:fillRef idx="3">
+            <a:schemeClr val="accent1"/>
+          </a:fillRef>
+          <a:effectRef idx="2">
+            <a:schemeClr val="accent1"/>
+          </a:effectRef>
+          <a:fontRef idx="minor">
+            <a:schemeClr val="lt1"/>
+          </a:fontRef>
+        </p:style>
+        <p:txBody>
+          <a:bodyPr rtlCol="0" anchor="ctr"/>
+          <a:lstStyle/>
+          <a:p>
+            <a:pPr algn="ctr"/>
+          </a:p>
+        </p:txBody>
+      </p:sp>
+      <p:sp>
+        <p:nvSpPr>
+          <p:cNvPr id="22" name="TextBox 21"/>
           <p:cNvSpPr txBox="1"/>
           <p:nvPr/>
         </p:nvSpPr>
         <p:spPr>
           <a:xfrm>
-            <a:off x="822960" y="2212848"/>
-            <a:ext cx="3017520" cy="219456"/>
+            <a:off x="877824" y="4133088"/>
+            <a:ext cx="402336" cy="365760"/>
+          </a:xfrm>
+          <a:prstGeom prst="rect">
+            <a:avLst/>
+          </a:prstGeom>
+          <a:noFill/>
+        </p:spPr>
+        <p:txBody>
+          <a:bodyPr wrap="square" lIns="0" rIns="0" tIns="0" bIns="0" anchor="ctr">
+            <a:normAutofit/>
+          </a:bodyPr>
+          <a:lstStyle/>
+          <a:p>
+            <a:pPr algn="ctr">
+              <a:lnSpc>
+                <a:spcPct val="100000"/>
+              </a:lnSpc>
+              <a:spcAft>
+                <a:spcPts val="144"/>
+              </a:spcAft>
+              <a:defRPr sz="1200" b="1">
+                <a:solidFill>
+                  <a:srgbClr val="FFFFFF"/>
+                </a:solidFill>
+                <a:latin typeface="Arial"/>
+              </a:defRPr>
+            </a:pPr>
+            <a:r>
+              <a:t>3</a:t>
+            </a:r>
+          </a:p>
+        </p:txBody>
+      </p:sp>
+      <p:sp>
+        <p:nvSpPr>
+          <p:cNvPr id="23" name="TextBox 22"/>
+          <p:cNvSpPr txBox="1"/>
+          <p:nvPr/>
+        </p:nvSpPr>
+        <p:spPr>
+          <a:xfrm>
+            <a:off x="1499616" y="4114800"/>
+            <a:ext cx="4206240" cy="365760"/>
+          </a:xfrm>
+          <a:prstGeom prst="rect">
+            <a:avLst/>
+          </a:prstGeom>
+          <a:noFill/>
+        </p:spPr>
+        <p:txBody>
+          <a:bodyPr wrap="square" lIns="0" rIns="0" tIns="0" bIns="0" anchor="t">
+            <a:normAutofit/>
+          </a:bodyPr>
+          <a:lstStyle/>
+          <a:p>
+            <a:pPr algn="l">
+              <a:lnSpc>
+                <a:spcPct val="100000"/>
+              </a:lnSpc>
+              <a:spcAft>
+                <a:spcPts val="192"/>
+              </a:spcAft>
+              <a:defRPr sz="1600" b="1">
+                <a:solidFill>
+                  <a:srgbClr val="17324D"/>
+                </a:solidFill>
+                <a:latin typeface="Arial"/>
+              </a:defRPr>
+            </a:pPr>
+            <a:r>
+              <a:t>El método se vigila solo</a:t>
+            </a:r>
+          </a:p>
+        </p:txBody>
+      </p:sp>
+      <p:sp>
+        <p:nvSpPr>
+          <p:cNvPr id="24" name="TextBox 23"/>
+          <p:cNvSpPr txBox="1"/>
+          <p:nvPr/>
+        </p:nvSpPr>
+        <p:spPr>
+          <a:xfrm>
+            <a:off x="1499616" y="4645152"/>
+            <a:ext cx="4206240" cy="731520"/>
+          </a:xfrm>
+          <a:prstGeom prst="rect">
+            <a:avLst/>
+          </a:prstGeom>
+          <a:noFill/>
+        </p:spPr>
+        <p:txBody>
+          <a:bodyPr wrap="square" lIns="0" rIns="0" tIns="0" bIns="0" anchor="t">
+            <a:normAutofit/>
+          </a:bodyPr>
+          <a:lstStyle/>
+          <a:p>
+            <a:pPr algn="l">
+              <a:lnSpc>
+                <a:spcPct val="100000"/>
+              </a:lnSpc>
+              <a:spcAft>
+                <a:spcPts val="126"/>
+              </a:spcAft>
+              <a:defRPr sz="1050" b="0">
+                <a:solidFill>
+                  <a:srgbClr val="3F556A"/>
+                </a:solidFill>
+                <a:latin typeface="Arial"/>
+              </a:defRPr>
+            </a:pPr>
+            <a:r>
+              <a:t>Doce controles en cada cambio impiden que se degrade en silencio. Antes dependía de que alguien se acordara de revisarlo.</a:t>
+            </a:r>
+          </a:p>
+        </p:txBody>
+      </p:sp>
+      <p:sp>
+        <p:nvSpPr>
+          <p:cNvPr id="25" name="Rounded Rectangle 24"/>
+          <p:cNvSpPr/>
+          <p:nvPr/>
+        </p:nvSpPr>
+        <p:spPr>
+          <a:xfrm>
+            <a:off x="6272784" y="3858768"/>
+            <a:ext cx="5358384" cy="1664208"/>
+          </a:xfrm>
+          <a:prstGeom prst="roundRect">
+            <a:avLst/>
+          </a:prstGeom>
+          <a:solidFill>
+            <a:srgbClr val="FFFFFF"/>
+          </a:solidFill>
+          <a:ln w="12700">
+            <a:solidFill>
+              <a:srgbClr val="D7DEE3"/>
+            </a:solidFill>
+          </a:ln>
+        </p:spPr>
+        <p:style>
+          <a:lnRef idx="1">
+            <a:schemeClr val="accent1"/>
+          </a:lnRef>
+          <a:fillRef idx="3">
+            <a:schemeClr val="accent1"/>
+          </a:fillRef>
+          <a:effectRef idx="2">
+            <a:schemeClr val="accent1"/>
+          </a:effectRef>
+          <a:fontRef idx="minor">
+            <a:schemeClr val="lt1"/>
+          </a:fontRef>
+        </p:style>
+        <p:txBody>
+          <a:bodyPr rtlCol="0" anchor="ctr"/>
+          <a:lstStyle/>
+          <a:p>
+            <a:pPr algn="ctr"/>
+          </a:p>
+        </p:txBody>
+      </p:sp>
+      <p:sp>
+        <p:nvSpPr>
+          <p:cNvPr id="26" name="Rectangle 25"/>
+          <p:cNvSpPr/>
+          <p:nvPr/>
+        </p:nvSpPr>
+        <p:spPr>
+          <a:xfrm>
+            <a:off x="6272784" y="3858768"/>
+            <a:ext cx="73152" cy="1664208"/>
+          </a:xfrm>
+          <a:prstGeom prst="rect">
+            <a:avLst/>
+          </a:prstGeom>
+          <a:solidFill>
+            <a:srgbClr val="16A9C7"/>
+          </a:solidFill>
+          <a:ln w="12700">
+            <a:solidFill>
+              <a:srgbClr val="16A9C7"/>
+            </a:solidFill>
+          </a:ln>
+        </p:spPr>
+        <p:style>
+          <a:lnRef idx="1">
+            <a:schemeClr val="accent1"/>
+          </a:lnRef>
+          <a:fillRef idx="3">
+            <a:schemeClr val="accent1"/>
+          </a:fillRef>
+          <a:effectRef idx="2">
+            <a:schemeClr val="accent1"/>
+          </a:effectRef>
+          <a:fontRef idx="minor">
+            <a:schemeClr val="lt1"/>
+          </a:fontRef>
+        </p:style>
+        <p:txBody>
+          <a:bodyPr rtlCol="0" anchor="ctr"/>
+          <a:lstStyle/>
+          <a:p>
+            <a:pPr algn="ctr"/>
+          </a:p>
+        </p:txBody>
+      </p:sp>
+      <p:sp>
+        <p:nvSpPr>
+          <p:cNvPr id="27" name="Oval 26"/>
+          <p:cNvSpPr/>
+          <p:nvPr/>
+        </p:nvSpPr>
+        <p:spPr>
+          <a:xfrm>
+            <a:off x="6583680" y="4114800"/>
+            <a:ext cx="402336" cy="402336"/>
+          </a:xfrm>
+          <a:prstGeom prst="ellipse">
+            <a:avLst/>
+          </a:prstGeom>
+          <a:solidFill>
+            <a:srgbClr val="16A9C7"/>
+          </a:solidFill>
+          <a:ln>
+            <a:solidFill>
+              <a:srgbClr val="16A9C7"/>
+            </a:solidFill>
+          </a:ln>
+        </p:spPr>
+        <p:style>
+          <a:lnRef idx="1">
+            <a:schemeClr val="accent1"/>
+          </a:lnRef>
+          <a:fillRef idx="3">
+            <a:schemeClr val="accent1"/>
+          </a:fillRef>
+          <a:effectRef idx="2">
+            <a:schemeClr val="accent1"/>
+          </a:effectRef>
+          <a:fontRef idx="minor">
+            <a:schemeClr val="lt1"/>
+          </a:fontRef>
+        </p:style>
+        <p:txBody>
+          <a:bodyPr rtlCol="0" anchor="ctr"/>
+          <a:lstStyle/>
+          <a:p>
+            <a:pPr algn="ctr"/>
+          </a:p>
+        </p:txBody>
+      </p:sp>
+      <p:sp>
+        <p:nvSpPr>
+          <p:cNvPr id="28" name="TextBox 27"/>
+          <p:cNvSpPr txBox="1"/>
+          <p:nvPr/>
+        </p:nvSpPr>
+        <p:spPr>
+          <a:xfrm>
+            <a:off x="6583680" y="4133088"/>
+            <a:ext cx="402336" cy="365760"/>
+          </a:xfrm>
+          <a:prstGeom prst="rect">
+            <a:avLst/>
+          </a:prstGeom>
+          <a:noFill/>
+        </p:spPr>
+        <p:txBody>
+          <a:bodyPr wrap="square" lIns="0" rIns="0" tIns="0" bIns="0" anchor="ctr">
+            <a:normAutofit/>
+          </a:bodyPr>
+          <a:lstStyle/>
+          <a:p>
+            <a:pPr algn="ctr">
+              <a:lnSpc>
+                <a:spcPct val="100000"/>
+              </a:lnSpc>
+              <a:spcAft>
+                <a:spcPts val="144"/>
+              </a:spcAft>
+              <a:defRPr sz="1200" b="1">
+                <a:solidFill>
+                  <a:srgbClr val="FFFFFF"/>
+                </a:solidFill>
+                <a:latin typeface="Arial"/>
+              </a:defRPr>
+            </a:pPr>
+            <a:r>
+              <a:t>4</a:t>
+            </a:r>
+          </a:p>
+        </p:txBody>
+      </p:sp>
+      <p:sp>
+        <p:nvSpPr>
+          <p:cNvPr id="29" name="TextBox 28"/>
+          <p:cNvSpPr txBox="1"/>
+          <p:nvPr/>
+        </p:nvSpPr>
+        <p:spPr>
+          <a:xfrm>
+            <a:off x="7205472" y="4114800"/>
+            <a:ext cx="4206240" cy="365760"/>
+          </a:xfrm>
+          <a:prstGeom prst="rect">
+            <a:avLst/>
+          </a:prstGeom>
+          <a:noFill/>
+        </p:spPr>
+        <p:txBody>
+          <a:bodyPr wrap="square" lIns="0" rIns="0" tIns="0" bIns="0" anchor="t">
+            <a:normAutofit/>
+          </a:bodyPr>
+          <a:lstStyle/>
+          <a:p>
+            <a:pPr algn="l">
+              <a:lnSpc>
+                <a:spcPct val="100000"/>
+              </a:lnSpc>
+              <a:spcAft>
+                <a:spcPts val="192"/>
+              </a:spcAft>
+              <a:defRPr sz="1600" b="1">
+                <a:solidFill>
+                  <a:srgbClr val="17324D"/>
+                </a:solidFill>
+                <a:latin typeface="Arial"/>
+              </a:defRPr>
+            </a:pPr>
+            <a:r>
+              <a:t>Escala sin reescribirse</a:t>
+            </a:r>
+          </a:p>
+        </p:txBody>
+      </p:sp>
+      <p:sp>
+        <p:nvSpPr>
+          <p:cNvPr id="30" name="TextBox 29"/>
+          <p:cNvSpPr txBox="1"/>
+          <p:nvPr/>
+        </p:nvSpPr>
+        <p:spPr>
+          <a:xfrm>
+            <a:off x="7205472" y="4645152"/>
+            <a:ext cx="4206240" cy="731520"/>
+          </a:xfrm>
+          <a:prstGeom prst="rect">
+            <a:avLst/>
+          </a:prstGeom>
+          <a:noFill/>
+        </p:spPr>
+        <p:txBody>
+          <a:bodyPr wrap="square" lIns="0" rIns="0" tIns="0" bIns="0" anchor="t">
+            <a:normAutofit/>
+          </a:bodyPr>
+          <a:lstStyle/>
+          <a:p>
+            <a:pPr algn="l">
+              <a:lnSpc>
+                <a:spcPct val="100000"/>
+              </a:lnSpc>
+              <a:spcAft>
+                <a:spcPts val="126"/>
+              </a:spcAft>
+              <a:defRPr sz="1050" b="0">
+                <a:solidFill>
+                  <a:srgbClr val="3F556A"/>
+                </a:solidFill>
+                <a:latin typeface="Arial"/>
+              </a:defRPr>
+            </a:pPr>
+            <a:r>
+              <a:t>Funciona con uno o con varios repositorios, con varias personas a la vez y en tres herramientas distintas de IA.</a:t>
+            </a:r>
+          </a:p>
+        </p:txBody>
+      </p:sp>
+      <p:sp>
+        <p:nvSpPr>
+          <p:cNvPr id="31" name="Rounded Rectangle 30"/>
+          <p:cNvSpPr/>
+          <p:nvPr/>
+        </p:nvSpPr>
+        <p:spPr>
+          <a:xfrm>
+            <a:off x="566928" y="5797296"/>
+            <a:ext cx="11064240" cy="548640"/>
+          </a:xfrm>
+          <a:prstGeom prst="roundRect">
+            <a:avLst/>
+          </a:prstGeom>
+          <a:solidFill>
+            <a:srgbClr val="FCE9DC"/>
+          </a:solidFill>
+          <a:ln w="12700">
+            <a:solidFill>
+              <a:srgbClr val="FCE9DC"/>
+            </a:solidFill>
+          </a:ln>
+        </p:spPr>
+        <p:style>
+          <a:lnRef idx="1">
+            <a:schemeClr val="accent1"/>
+          </a:lnRef>
+          <a:fillRef idx="3">
+            <a:schemeClr val="accent1"/>
+          </a:fillRef>
+          <a:effectRef idx="2">
+            <a:schemeClr val="accent1"/>
+          </a:effectRef>
+          <a:fontRef idx="minor">
+            <a:schemeClr val="lt1"/>
+          </a:fontRef>
+        </p:style>
+        <p:txBody>
+          <a:bodyPr rtlCol="0" anchor="ctr"/>
+          <a:lstStyle/>
+          <a:p>
+            <a:pPr algn="ctr"/>
+          </a:p>
+        </p:txBody>
+      </p:sp>
+      <p:sp>
+        <p:nvSpPr>
+          <p:cNvPr id="32" name="TextBox 31"/>
+          <p:cNvSpPr txBox="1"/>
+          <p:nvPr/>
+        </p:nvSpPr>
+        <p:spPr>
+          <a:xfrm>
+            <a:off x="841248" y="5907024"/>
+            <a:ext cx="10515600" cy="310896"/>
+          </a:xfrm>
+          <a:prstGeom prst="rect">
+            <a:avLst/>
+          </a:prstGeom>
+          <a:noFill/>
+        </p:spPr>
+        <p:txBody>
+          <a:bodyPr wrap="square" lIns="0" rIns="0" tIns="0" bIns="0" anchor="ctr">
+            <a:normAutofit/>
+          </a:bodyPr>
+          <a:lstStyle/>
+          <a:p>
+            <a:pPr algn="ctr">
+              <a:lnSpc>
+                <a:spcPct val="100000"/>
+              </a:lnSpc>
+              <a:spcAft>
+                <a:spcPts val="144"/>
+              </a:spcAft>
+              <a:defRPr sz="1200" b="1">
+                <a:solidFill>
+                  <a:srgbClr val="17324D"/>
+                </a:solidFill>
+                <a:latin typeface="Arial"/>
+              </a:defRPr>
+            </a:pPr>
+            <a:r>
+              <a:t>En una línea  ·  El método sabía construir software sin desviarse de lo pedido. Ahora también sabe demostrarlo.</a:t>
+            </a:r>
+          </a:p>
+        </p:txBody>
+      </p:sp>
+      <p:sp>
+        <p:nvSpPr>
+          <p:cNvPr id="33" name="TextBox 32"/>
+          <p:cNvSpPr txBox="1"/>
+          <p:nvPr/>
+        </p:nvSpPr>
+        <p:spPr>
+          <a:xfrm>
+            <a:off x="502920" y="6528816"/>
+            <a:ext cx="8961120" cy="164592"/>
+          </a:xfrm>
+          <a:prstGeom prst="rect">
+            <a:avLst/>
+          </a:prstGeom>
+          <a:noFill/>
+        </p:spPr>
+        <p:txBody>
+          <a:bodyPr wrap="square" lIns="0" rIns="0" tIns="0" bIns="0" anchor="t">
+            <a:normAutofit/>
+          </a:bodyPr>
+          <a:lstStyle/>
+          <a:p>
+            <a:pPr algn="l">
+              <a:lnSpc>
+                <a:spcPct val="100000"/>
+              </a:lnSpc>
+              <a:spcAft>
+                <a:spcPts val="81"/>
+              </a:spcAft>
+              <a:defRPr sz="680" b="0">
+                <a:solidFill>
+                  <a:srgbClr val="71808E"/>
+                </a:solidFill>
+                <a:latin typeface="Arial"/>
+              </a:defRPr>
+            </a:pPr>
+            <a:r>
+              <a:t>El detalle, mejora a mejora, está en el informe: evolucion-native-ai.html</a:t>
+            </a:r>
+          </a:p>
+        </p:txBody>
+      </p:sp>
+      <p:sp>
+        <p:nvSpPr>
+          <p:cNvPr id="34" name="TextBox 33"/>
+          <p:cNvSpPr txBox="1"/>
+          <p:nvPr/>
+        </p:nvSpPr>
+        <p:spPr>
+          <a:xfrm>
+            <a:off x="10744200" y="6492240"/>
+            <a:ext cx="914400" cy="201168"/>
+          </a:xfrm>
+          <a:prstGeom prst="rect">
+            <a:avLst/>
+          </a:prstGeom>
+          <a:noFill/>
+        </p:spPr>
+        <p:txBody>
+          <a:bodyPr wrap="square" lIns="0" rIns="0" tIns="0" bIns="0" anchor="t">
+            <a:normAutofit/>
+          </a:bodyPr>
+          <a:lstStyle/>
+          <a:p>
+            <a:pPr algn="r">
+              <a:lnSpc>
+                <a:spcPct val="100000"/>
+              </a:lnSpc>
+              <a:spcAft>
+                <a:spcPts val="86"/>
+              </a:spcAft>
+              <a:defRPr sz="720" b="1">
+                <a:solidFill>
+                  <a:srgbClr val="71808E"/>
+                </a:solidFill>
+                <a:latin typeface="Arial"/>
+              </a:defRPr>
+            </a:pPr>
+            <a:r>
+              <a:t>05 / 06</a:t>
+            </a:r>
+          </a:p>
+        </p:txBody>
+      </p:sp>
+    </p:spTree>
+  </p:cSld>
+  <p:clrMapOvr>
+    <a:masterClrMapping/>
+  </p:clrMapOvr>
+</p:sld>
+</file>
+
+<file path=ppt/slides/slide6.xml><?xml version="1.0" encoding="utf-8"?>
+<p:sld xmlns:a="http://schemas.openxmlformats.org/drawingml/2006/main" xmlns:p="http://schemas.openxmlformats.org/presentationml/2006/main" xmlns:r="http://schemas.openxmlformats.org/officeDocument/2006/relationships">
+  <p:cSld>
+    <p:spTree>
+      <p:nvGrpSpPr>
+        <p:cNvPr id="1" name=""/>
+        <p:cNvGrpSpPr/>
+        <p:nvPr/>
+      </p:nvGrpSpPr>
+      <p:grpSpPr/>
+      <p:sp>
+        <p:nvSpPr>
+          <p:cNvPr id="2" name="Rectangle 1"/>
+          <p:cNvSpPr/>
+          <p:nvPr/>
+        </p:nvSpPr>
+        <p:spPr>
+          <a:xfrm>
+            <a:off x="0" y="0"/>
+            <a:ext cx="12191695" cy="6858000"/>
+          </a:xfrm>
+          <a:prstGeom prst="rect">
+            <a:avLst/>
+          </a:prstGeom>
+          <a:solidFill>
+            <a:srgbClr val="F6F4EF"/>
+          </a:solidFill>
+          <a:ln w="12700">
+            <a:solidFill>
+              <a:srgbClr val="F6F4EF"/>
+            </a:solidFill>
+          </a:ln>
+        </p:spPr>
+        <p:style>
+          <a:lnRef idx="1">
+            <a:schemeClr val="accent1"/>
+          </a:lnRef>
+          <a:fillRef idx="3">
+            <a:schemeClr val="accent1"/>
+          </a:fillRef>
+          <a:effectRef idx="2">
+            <a:schemeClr val="accent1"/>
+          </a:effectRef>
+          <a:fontRef idx="minor">
+            <a:schemeClr val="lt1"/>
+          </a:fontRef>
+        </p:style>
+        <p:txBody>
+          <a:bodyPr rtlCol="0" anchor="ctr"/>
+          <a:lstStyle/>
+          <a:p>
+            <a:pPr algn="ctr"/>
+          </a:p>
+        </p:txBody>
+      </p:sp>
+      <p:sp>
+        <p:nvSpPr>
+          <p:cNvPr id="3" name="TextBox 2"/>
+          <p:cNvSpPr txBox="1"/>
+          <p:nvPr/>
+        </p:nvSpPr>
+        <p:spPr>
+          <a:xfrm>
+            <a:off x="502920" y="274320"/>
+            <a:ext cx="2926080" cy="228600"/>
           </a:xfrm>
           <a:prstGeom prst="rect">
             <a:avLst/>
@@ -10025,6 +11568,265 @@
               </a:spcAft>
               <a:defRPr sz="900" b="1">
                 <a:solidFill>
+                  <a:srgbClr val="0072BC"/>
+                </a:solidFill>
+                <a:latin typeface="Arial"/>
+              </a:defRPr>
+            </a:pPr>
+            <a:r>
+              <a:t>DÓNDE ESTAMOS</a:t>
+            </a:r>
+          </a:p>
+        </p:txBody>
+      </p:sp>
+      <p:sp>
+        <p:nvSpPr>
+          <p:cNvPr id="4" name="TextBox 3"/>
+          <p:cNvSpPr txBox="1"/>
+          <p:nvPr/>
+        </p:nvSpPr>
+        <p:spPr>
+          <a:xfrm>
+            <a:off x="502920" y="658368"/>
+            <a:ext cx="11064240" cy="530352"/>
+          </a:xfrm>
+          <a:prstGeom prst="rect">
+            <a:avLst/>
+          </a:prstGeom>
+          <a:noFill/>
+        </p:spPr>
+        <p:txBody>
+          <a:bodyPr wrap="square" lIns="0" rIns="0" tIns="0" bIns="0" anchor="t">
+            <a:normAutofit/>
+          </a:bodyPr>
+          <a:lstStyle/>
+          <a:p>
+            <a:pPr algn="l">
+              <a:lnSpc>
+                <a:spcPct val="100000"/>
+              </a:lnSpc>
+              <a:spcAft>
+                <a:spcPts val="300"/>
+              </a:spcAft>
+              <a:defRPr sz="2500" b="1">
+                <a:solidFill>
+                  <a:srgbClr val="17324D"/>
+                </a:solidFill>
+                <a:latin typeface="Arial"/>
+              </a:defRPr>
+            </a:pPr>
+            <a:r>
+              <a:t>Está en uso, se instala en un comando y sigue creciendo</a:t>
+            </a:r>
+          </a:p>
+        </p:txBody>
+      </p:sp>
+      <p:sp>
+        <p:nvSpPr>
+          <p:cNvPr id="5" name="TextBox 4"/>
+          <p:cNvSpPr txBox="1"/>
+          <p:nvPr/>
+        </p:nvSpPr>
+        <p:spPr>
+          <a:xfrm>
+            <a:off x="502920" y="1170432"/>
+            <a:ext cx="10972800" cy="411480"/>
+          </a:xfrm>
+          <a:prstGeom prst="rect">
+            <a:avLst/>
+          </a:prstGeom>
+          <a:noFill/>
+        </p:spPr>
+        <p:txBody>
+          <a:bodyPr wrap="square" lIns="0" rIns="0" tIns="0" bIns="0" anchor="t">
+            <a:normAutofit/>
+          </a:bodyPr>
+          <a:lstStyle/>
+          <a:p>
+            <a:pPr algn="l">
+              <a:lnSpc>
+                <a:spcPct val="100000"/>
+              </a:lnSpc>
+              <a:spcAft>
+                <a:spcPts val="126"/>
+              </a:spcAft>
+              <a:defRPr sz="1050" b="0">
+                <a:solidFill>
+                  <a:srgbClr val="3F556A"/>
+                </a:solidFill>
+                <a:latin typeface="Arial"/>
+              </a:defRPr>
+            </a:pPr>
+            <a:r>
+              <a:t>No es un piloto ni una prueba de concepto: está publicado, versionado y funcionando en proyecto.</a:t>
+            </a:r>
+          </a:p>
+        </p:txBody>
+      </p:sp>
+      <p:sp>
+        <p:nvSpPr>
+          <p:cNvPr id="6" name="Rectangle 5"/>
+          <p:cNvSpPr/>
+          <p:nvPr/>
+        </p:nvSpPr>
+        <p:spPr>
+          <a:xfrm>
+            <a:off x="502920" y="1627632"/>
+            <a:ext cx="11183111" cy="1828"/>
+          </a:xfrm>
+          <a:prstGeom prst="rect">
+            <a:avLst/>
+          </a:prstGeom>
+          <a:solidFill>
+            <a:srgbClr val="D7DEE3"/>
+          </a:solidFill>
+          <a:ln>
+            <a:noFill/>
+          </a:ln>
+        </p:spPr>
+        <p:style>
+          <a:lnRef idx="1">
+            <a:schemeClr val="accent1"/>
+          </a:lnRef>
+          <a:fillRef idx="3">
+            <a:schemeClr val="accent1"/>
+          </a:fillRef>
+          <a:effectRef idx="2">
+            <a:schemeClr val="accent1"/>
+          </a:effectRef>
+          <a:fontRef idx="minor">
+            <a:schemeClr val="lt1"/>
+          </a:fontRef>
+        </p:style>
+        <p:txBody>
+          <a:bodyPr rtlCol="0" anchor="ctr"/>
+          <a:lstStyle/>
+          <a:p>
+            <a:pPr algn="ctr"/>
+          </a:p>
+        </p:txBody>
+      </p:sp>
+      <p:sp>
+        <p:nvSpPr>
+          <p:cNvPr id="7" name="Rounded Rectangle 6"/>
+          <p:cNvSpPr/>
+          <p:nvPr/>
+        </p:nvSpPr>
+        <p:spPr>
+          <a:xfrm>
+            <a:off x="566928" y="1956816"/>
+            <a:ext cx="3529584" cy="2048256"/>
+          </a:xfrm>
+          <a:prstGeom prst="roundRect">
+            <a:avLst/>
+          </a:prstGeom>
+          <a:solidFill>
+            <a:srgbClr val="FFFFFF"/>
+          </a:solidFill>
+          <a:ln w="12700">
+            <a:solidFill>
+              <a:srgbClr val="D7DEE3"/>
+            </a:solidFill>
+          </a:ln>
+        </p:spPr>
+        <p:style>
+          <a:lnRef idx="1">
+            <a:schemeClr val="accent1"/>
+          </a:lnRef>
+          <a:fillRef idx="3">
+            <a:schemeClr val="accent1"/>
+          </a:fillRef>
+          <a:effectRef idx="2">
+            <a:schemeClr val="accent1"/>
+          </a:effectRef>
+          <a:fontRef idx="minor">
+            <a:schemeClr val="lt1"/>
+          </a:fontRef>
+        </p:style>
+        <p:txBody>
+          <a:bodyPr rtlCol="0" anchor="ctr"/>
+          <a:lstStyle/>
+          <a:p>
+            <a:pPr algn="ctr"/>
+          </a:p>
+        </p:txBody>
+      </p:sp>
+      <p:sp>
+        <p:nvSpPr>
+          <p:cNvPr id="8" name="Rectangle 7"/>
+          <p:cNvSpPr/>
+          <p:nvPr/>
+        </p:nvSpPr>
+        <p:spPr>
+          <a:xfrm>
+            <a:off x="566928" y="1956816"/>
+            <a:ext cx="3529584" cy="73152"/>
+          </a:xfrm>
+          <a:prstGeom prst="rect">
+            <a:avLst/>
+          </a:prstGeom>
+          <a:solidFill>
+            <a:srgbClr val="008F83"/>
+          </a:solidFill>
+          <a:ln w="12700">
+            <a:solidFill>
+              <a:srgbClr val="008F83"/>
+            </a:solidFill>
+          </a:ln>
+        </p:spPr>
+        <p:style>
+          <a:lnRef idx="1">
+            <a:schemeClr val="accent1"/>
+          </a:lnRef>
+          <a:fillRef idx="3">
+            <a:schemeClr val="accent1"/>
+          </a:fillRef>
+          <a:effectRef idx="2">
+            <a:schemeClr val="accent1"/>
+          </a:effectRef>
+          <a:fontRef idx="minor">
+            <a:schemeClr val="lt1"/>
+          </a:fontRef>
+        </p:style>
+        <p:txBody>
+          <a:bodyPr rtlCol="0" anchor="ctr"/>
+          <a:lstStyle/>
+          <a:p>
+            <a:pPr algn="ctr"/>
+          </a:p>
+        </p:txBody>
+      </p:sp>
+      <p:sp>
+        <p:nvSpPr>
+          <p:cNvPr id="9" name="TextBox 8"/>
+          <p:cNvSpPr txBox="1"/>
+          <p:nvPr/>
+        </p:nvSpPr>
+        <p:spPr>
+          <a:xfrm>
+            <a:off x="822960" y="2212848"/>
+            <a:ext cx="3017520" cy="219456"/>
+          </a:xfrm>
+          <a:prstGeom prst="rect">
+            <a:avLst/>
+          </a:prstGeom>
+          <a:noFill/>
+        </p:spPr>
+        <p:txBody>
+          <a:bodyPr wrap="square" lIns="0" rIns="0" tIns="0" bIns="0" anchor="t">
+            <a:normAutofit/>
+          </a:bodyPr>
+          <a:lstStyle/>
+          <a:p>
+            <a:pPr algn="l">
+              <a:lnSpc>
+                <a:spcPct val="100000"/>
+              </a:lnSpc>
+              <a:spcAft>
+                <a:spcPts val="108"/>
+              </a:spcAft>
+              <a:defRPr sz="900" b="1">
+                <a:solidFill>
                   <a:srgbClr val="008F83"/>
                 </a:solidFill>
                 <a:latin typeface="Arial"/>
@@ -10934,7 +12736,7 @@
               </a:defRPr>
             </a:pPr>
             <a:r>
-              <a:t>05 / 05</a:t>
+              <a:t>06 / 06</a:t>
             </a:r>
           </a:p>
         </p:txBody>

</xml_diff>